<commit_message>
Finalize student details and presentation evidence
</commit_message>
<xml_diff>
--- a/report/presentation/bean_leaf_presentation.pptx
+++ b/report/presentation/bean_leaf_presentation.pptx
@@ -2,24 +2,26 @@
 <file path=ppt/presentation.xml><?xml version="1.0" encoding="utf-8"?>
 <p:presentation xmlns:p="http://schemas.openxmlformats.org/presentationml/2006/main">
   <p:sldMasterIdLst>
-    <p:sldMasterId xmlns:r="http://schemas.openxmlformats.org/officeDocument/2006/relationships" id="2147483648" r:id="R1fd6c3489d01442f"/>
+    <p:sldMasterId xmlns:r="http://schemas.openxmlformats.org/officeDocument/2006/relationships" id="2147483648" r:id="R8d1e29fb2610412a"/>
   </p:sldMasterIdLst>
   <p:notesMasterIdLst>
-    <p:notesMasterId xmlns:r="http://schemas.openxmlformats.org/officeDocument/2006/relationships" r:id="R829207944af348e6"/>
+    <p:notesMasterId xmlns:r="http://schemas.openxmlformats.org/officeDocument/2006/relationships" r:id="Raeed584cf18a40c8"/>
   </p:notesMasterIdLst>
   <p:sldIdLst>
-    <p:sldId xmlns:r="http://schemas.openxmlformats.org/officeDocument/2006/relationships" id="256" r:id="Rc6b8d72aaaaa40e2"/>
-    <p:sldId xmlns:r="http://schemas.openxmlformats.org/officeDocument/2006/relationships" id="257" r:id="R57a1cabfd5ad4606"/>
-    <p:sldId xmlns:r="http://schemas.openxmlformats.org/officeDocument/2006/relationships" id="258" r:id="Re4a416ec78194903"/>
-    <p:sldId xmlns:r="http://schemas.openxmlformats.org/officeDocument/2006/relationships" id="259" r:id="Rde964652203a419d"/>
-    <p:sldId xmlns:r="http://schemas.openxmlformats.org/officeDocument/2006/relationships" id="260" r:id="R72c4c44913694afe"/>
-    <p:sldId xmlns:r="http://schemas.openxmlformats.org/officeDocument/2006/relationships" id="261" r:id="R8b97d69c6afa4ad2"/>
-    <p:sldId xmlns:r="http://schemas.openxmlformats.org/officeDocument/2006/relationships" id="262" r:id="R965f5c467e1c4cbd"/>
-    <p:sldId xmlns:r="http://schemas.openxmlformats.org/officeDocument/2006/relationships" id="263" r:id="Re468cf380919413a"/>
-    <p:sldId xmlns:r="http://schemas.openxmlformats.org/officeDocument/2006/relationships" id="264" r:id="R27f42ee924914a6a"/>
-    <p:sldId xmlns:r="http://schemas.openxmlformats.org/officeDocument/2006/relationships" id="265" r:id="R032bf380d801423a"/>
-    <p:sldId xmlns:r="http://schemas.openxmlformats.org/officeDocument/2006/relationships" id="266" r:id="R72f77382fc124b71"/>
-    <p:sldId xmlns:r="http://schemas.openxmlformats.org/officeDocument/2006/relationships" id="267" r:id="R63ebcc9daac24e52"/>
+    <p:sldId xmlns:r="http://schemas.openxmlformats.org/officeDocument/2006/relationships" id="256" r:id="R8c6761a122064e61"/>
+    <p:sldId xmlns:r="http://schemas.openxmlformats.org/officeDocument/2006/relationships" id="257" r:id="R20b70ea2929f4f6a"/>
+    <p:sldId xmlns:r="http://schemas.openxmlformats.org/officeDocument/2006/relationships" id="258" r:id="Rfc47d71c478c472a"/>
+    <p:sldId xmlns:r="http://schemas.openxmlformats.org/officeDocument/2006/relationships" id="259" r:id="R516643924a0c4969"/>
+    <p:sldId xmlns:r="http://schemas.openxmlformats.org/officeDocument/2006/relationships" id="260" r:id="R3c38a85682f54675"/>
+    <p:sldId xmlns:r="http://schemas.openxmlformats.org/officeDocument/2006/relationships" id="261" r:id="R461f2e87ed83426e"/>
+    <p:sldId xmlns:r="http://schemas.openxmlformats.org/officeDocument/2006/relationships" id="262" r:id="Rbc92ec54a8f14f89"/>
+    <p:sldId xmlns:r="http://schemas.openxmlformats.org/officeDocument/2006/relationships" id="263" r:id="Rdc2415126a0640d9"/>
+    <p:sldId xmlns:r="http://schemas.openxmlformats.org/officeDocument/2006/relationships" id="264" r:id="R2e368fee74a24384"/>
+    <p:sldId xmlns:r="http://schemas.openxmlformats.org/officeDocument/2006/relationships" id="265" r:id="Rc3791ca9d4364217"/>
+    <p:sldId xmlns:r="http://schemas.openxmlformats.org/officeDocument/2006/relationships" id="266" r:id="R2cb639a7cdcf425d"/>
+    <p:sldId xmlns:r="http://schemas.openxmlformats.org/officeDocument/2006/relationships" id="267" r:id="R33d6c93197dd41be"/>
+    <p:sldId xmlns:r="http://schemas.openxmlformats.org/officeDocument/2006/relationships" id="268" r:id="Rbb972cc46b4a4a49"/>
+    <p:sldId xmlns:r="http://schemas.openxmlformats.org/officeDocument/2006/relationships" id="269" r:id="Rcae02aa00ffe4546"/>
   </p:sldIdLst>
   <p:sldSz cx="12192000" cy="6858000"/>
   <p:notesSz cx="6858000" cy="9144000"/>
@@ -758,6 +760,211 @@
           <a:lstStyle xmlns:a="http://schemas.openxmlformats.org/drawingml/2006/main"/>
           <a:p xmlns:a="http://schemas.openxmlformats.org/drawingml/2006/main">
             <a:r>
+              <a:t>These are the partial-model results for reference seed seventeen. Precision measures how often a predicted class is correct. Recall measures how many true examples of that class were found. F1 combines both. Leaf-spot recall is 97.67 percent for DINOv2 and 93.02 for SigLIP 2. The training-majority baseline always predicts rust, achieving 33.59 percent accuracy and 16.76 percent macro-F1. These class results describe one seed on this small test set.</a:t>
+            </a:r>
+          </a:p>
+          <a:p xmlns:a="http://schemas.openxmlformats.org/drawingml/2006/main">
+            <a:r>
+              <a:t/>
+            </a:r>
+          </a:p>
+          <a:p xmlns:a="http://schemas.openxmlformats.org/drawingml/2006/main">
+            <a:r>
+              <a:t>Sources</a:t>
+            </a:r>
+          </a:p>
+          <a:p xmlns:a="http://schemas.openxmlformats.org/drawingml/2006/main">
+            <a:r>
+              <a:t>results/model_comparison/comparison_analysis.json</a:t>
+            </a:r>
+          </a:p>
+          <a:p xmlns:a="http://schemas.openxmlformats.org/drawingml/2006/main">
+            <a:r>
+              <a:t>results/model_comparison/dinov2/runs/partial/seed_17/metrics_test.json</a:t>
+            </a:r>
+          </a:p>
+          <a:p xmlns:a="http://schemas.openxmlformats.org/drawingml/2006/main">
+            <a:r>
+              <a:t>results/model_comparison/siglip2/runs/partial/seed_17/metrics_test.json</a:t>
+            </a:r>
+          </a:p>
+        </p:txBody>
+      </p:sp>
+      <p:sp>
+        <p:nvSpPr>
+          <p:cNvPr id="4" name="Slide Number Placeholder 3"/>
+          <p:cNvSpPr>
+            <a:spLocks xmlns:a="http://schemas.openxmlformats.org/drawingml/2006/main" noGrp="1"/>
+          </p:cNvSpPr>
+          <p:nvPr>
+            <p:ph type="sldNum" idx="5"/>
+          </p:nvPr>
+        </p:nvSpPr>
+        <p:spPr/>
+        <p:txBody>
+          <a:bodyPr xmlns:a="http://schemas.openxmlformats.org/drawingml/2006/main"/>
+          <a:lstStyle xmlns:a="http://schemas.openxmlformats.org/drawingml/2006/main"/>
+          <a:p xmlns:a="http://schemas.openxmlformats.org/drawingml/2006/main"/>
+        </p:txBody>
+      </p:sp>
+    </p:spTree>
+  </p:cSld>
+  <p:clrMapOvr>
+    <a:masterClrMapping xmlns:a="http://schemas.openxmlformats.org/drawingml/2006/main"/>
+  </p:clrMapOvr>
+</p:notes>
+</file>
+
+<file path=ppt/notesSlides/notesSlide13.xml><?xml version="1.0" encoding="utf-8"?>
+<p:notes xmlns:p="http://schemas.openxmlformats.org/presentationml/2006/main">
+  <p:cSld>
+    <p:spTree>
+      <p:nvGrpSpPr>
+        <p:cNvPr id="1" name=""/>
+        <p:cNvGrpSpPr/>
+        <p:nvPr/>
+      </p:nvGrpSpPr>
+      <p:grpSpPr>
+        <a:xfrm xmlns:a="http://schemas.openxmlformats.org/drawingml/2006/main"/>
+      </p:grpSpPr>
+      <p:sp>
+        <p:nvSpPr>
+          <p:cNvPr id="2" name="Slide Image Placeholder 1"/>
+          <p:cNvSpPr>
+            <a:spLocks xmlns:a="http://schemas.openxmlformats.org/drawingml/2006/main" noGrp="1"/>
+          </p:cNvSpPr>
+          <p:nvPr>
+            <p:ph type="sldImg" idx="0"/>
+          </p:nvPr>
+        </p:nvSpPr>
+        <p:spPr/>
+      </p:sp>
+      <p:sp>
+        <p:nvSpPr>
+          <p:cNvPr id="3" name="Notes Placeholder 2"/>
+          <p:cNvSpPr>
+            <a:spLocks xmlns:a="http://schemas.openxmlformats.org/drawingml/2006/main" noGrp="1"/>
+          </p:cNvSpPr>
+          <p:nvPr>
+            <p:ph type="body" idx="1"/>
+          </p:nvPr>
+        </p:nvSpPr>
+        <p:spPr/>
+        <p:txBody>
+          <a:bodyPr xmlns:a="http://schemas.openxmlformats.org/drawingml/2006/main"/>
+          <a:lstStyle xmlns:a="http://schemas.openxmlformats.org/drawingml/2006/main"/>
+          <a:p xmlns:a="http://schemas.openxmlformats.org/drawingml/2006/main">
+            <a:r>
+              <a:t>For the reference seed-seventeen partial models, DINOv2 macro-F1 is 98.45 percent on clean images, 97.67 under Gaussian blur of radius one, and 98.45 after brightness is multiplied by 0.7. SigLIP 2 scores 97.67, 96.07 and 97.67 percent. These changes use the same 128 test images at one synthetic severity each. They do not establish performance across independent farms, devices, seasons or other image changes.</a:t>
+            </a:r>
+          </a:p>
+          <a:p xmlns:a="http://schemas.openxmlformats.org/drawingml/2006/main">
+            <a:r>
+              <a:t/>
+            </a:r>
+          </a:p>
+          <a:p xmlns:a="http://schemas.openxmlformats.org/drawingml/2006/main">
+            <a:r>
+              <a:t>Sources</a:t>
+            </a:r>
+          </a:p>
+          <a:p xmlns:a="http://schemas.openxmlformats.org/drawingml/2006/main">
+            <a:r>
+              <a:t>results/model_comparison/dinov2/runs/partial/seed_17/metrics_test.json</a:t>
+            </a:r>
+          </a:p>
+          <a:p xmlns:a="http://schemas.openxmlformats.org/drawingml/2006/main">
+            <a:r>
+              <a:t>results/model_comparison/dinov2/runs/partial/seed_17/metrics_test_blur.json</a:t>
+            </a:r>
+          </a:p>
+          <a:p xmlns:a="http://schemas.openxmlformats.org/drawingml/2006/main">
+            <a:r>
+              <a:t>results/model_comparison/dinov2/runs/partial/seed_17/metrics_test_brightness.json</a:t>
+            </a:r>
+          </a:p>
+          <a:p xmlns:a="http://schemas.openxmlformats.org/drawingml/2006/main">
+            <a:r>
+              <a:t>results/model_comparison/siglip2/runs/partial/seed_17/metrics_test.json</a:t>
+            </a:r>
+          </a:p>
+          <a:p xmlns:a="http://schemas.openxmlformats.org/drawingml/2006/main">
+            <a:r>
+              <a:t>results/model_comparison/siglip2/runs/partial/seed_17/metrics_test_blur.json</a:t>
+            </a:r>
+          </a:p>
+          <a:p xmlns:a="http://schemas.openxmlformats.org/drawingml/2006/main">
+            <a:r>
+              <a:t>results/model_comparison/siglip2/runs/partial/seed_17/metrics_test_brightness.json</a:t>
+            </a:r>
+          </a:p>
+        </p:txBody>
+      </p:sp>
+      <p:sp>
+        <p:nvSpPr>
+          <p:cNvPr id="4" name="Slide Number Placeholder 3"/>
+          <p:cNvSpPr>
+            <a:spLocks xmlns:a="http://schemas.openxmlformats.org/drawingml/2006/main" noGrp="1"/>
+          </p:cNvSpPr>
+          <p:nvPr>
+            <p:ph type="sldNum" idx="5"/>
+          </p:nvPr>
+        </p:nvSpPr>
+        <p:spPr/>
+        <p:txBody>
+          <a:bodyPr xmlns:a="http://schemas.openxmlformats.org/drawingml/2006/main"/>
+          <a:lstStyle xmlns:a="http://schemas.openxmlformats.org/drawingml/2006/main"/>
+          <a:p xmlns:a="http://schemas.openxmlformats.org/drawingml/2006/main"/>
+        </p:txBody>
+      </p:sp>
+    </p:spTree>
+  </p:cSld>
+  <p:clrMapOvr>
+    <a:masterClrMapping xmlns:a="http://schemas.openxmlformats.org/drawingml/2006/main"/>
+  </p:clrMapOvr>
+</p:notes>
+</file>
+
+<file path=ppt/notesSlides/notesSlide14.xml><?xml version="1.0" encoding="utf-8"?>
+<p:notes xmlns:p="http://schemas.openxmlformats.org/presentationml/2006/main">
+  <p:cSld>
+    <p:spTree>
+      <p:nvGrpSpPr>
+        <p:cNvPr id="1" name=""/>
+        <p:cNvGrpSpPr/>
+        <p:nvPr/>
+      </p:nvGrpSpPr>
+      <p:grpSpPr>
+        <a:xfrm xmlns:a="http://schemas.openxmlformats.org/drawingml/2006/main"/>
+      </p:grpSpPr>
+      <p:sp>
+        <p:nvSpPr>
+          <p:cNvPr id="2" name="Slide Image Placeholder 1"/>
+          <p:cNvSpPr>
+            <a:spLocks xmlns:a="http://schemas.openxmlformats.org/drawingml/2006/main" noGrp="1"/>
+          </p:cNvSpPr>
+          <p:nvPr>
+            <p:ph type="sldImg" idx="0"/>
+          </p:nvPr>
+        </p:nvSpPr>
+        <p:spPr/>
+      </p:sp>
+      <p:sp>
+        <p:nvSpPr>
+          <p:cNvPr id="3" name="Notes Placeholder 2"/>
+          <p:cNvSpPr>
+            <a:spLocks xmlns:a="http://schemas.openxmlformats.org/drawingml/2006/main" noGrp="1"/>
+          </p:cNvSpPr>
+          <p:nvPr>
+            <p:ph type="body" idx="1"/>
+          </p:nvPr>
+        </p:nvSpPr>
+        <p:spPr/>
+        <p:txBody>
+          <a:bodyPr xmlns:a="http://schemas.openxmlformats.org/drawingml/2006/main"/>
+          <a:lstStyle xmlns:a="http://schemas.openxmlformats.org/drawingml/2006/main"/>
+          <a:p xmlns:a="http://schemas.openxmlformats.org/drawingml/2006/main">
+            <a:r>
               <a:t>Selected primary references for the presentation. The technical report contains the complete bibliography and pinned processor/implementation sources. Photograph attribution: Makerere AI Lab and dataset contributors. Dataset MIT and model Apache 2.0 notices accompany the project. AI-assisted implementation and drafting are disclosed in ASSISTANCE.md. No claim is made that the project used the latest available October 2026 model or established state-of-the-art Beans performance.</a:t>
             </a:r>
           </a:p>
@@ -868,7 +1075,7 @@
           <a:lstStyle xmlns:a="http://schemas.openxmlformats.org/drawingml/2006/main"/>
           <a:p xmlns:a="http://schemas.openxmlformats.org/drawingml/2006/main">
             <a:r>
-              <a:t>The task has three labels: angular leaf spot, bean rust and healthy. The photographs come from Ugandan fields, with varied backgrounds and lighting. The audited release contains 1,295 images. I kept the published split: 1,034 training, 133 validation and 128 test images. Every split contains all three classes. There were no corrupt files or exact duplicates. However, farm and plant identifiers are unavailable, so we cannot verify that the test images come from separate farms.</a:t>
+              <a:t>The task has three labels: angular leaf spot, bean rust and healthy. I chose this small, expert-labelled dataset because field photographs have varied backgrounds and lighting, and transfer learning is feasible with limited computing. The audited release contains 1,295 images. I kept the published split: 1,034 training, 133 validation and 128 test images. Every split contains all three classes. There were no corrupt files or exact duplicates. However, farm and plant identifiers are unavailable, so we cannot verify that test images come from separate farms.</a:t>
             </a:r>
           </a:p>
           <a:p xmlns:a="http://schemas.openxmlformats.org/drawingml/2006/main">
@@ -963,7 +1170,7 @@
           <a:lstStyle xmlns:a="http://schemas.openxmlformats.org/drawingml/2006/main"/>
           <a:p xmlns:a="http://schemas.openxmlformats.org/drawingml/2006/main">
             <a:r>
-              <a:t>Both models start from public pretrained weights. The encoder turns image pixels into numerical features. A new classifier uses those features to predict the three labels. Frozen training changes only the classifier weights. Partial fine-tuning also changes the final two encoder blocks and final normalisation. Each setting starts again from the original pretrained checkpoint. SigLIP 2 supports text, but this experiment uses only its image encoder. Both models receive 224-pixel images with matching flips and rotations. Three seeds for each model and setting give twelve runs. Validation performance selects the saved model in each run.</a:t>
+              <a:t>SigLIP 2 is a public advanced model from 2025. DINOv2 is an established comparison. The SigLIP 2 paper reports 78.2 percent ImageNet zero-shot accuracy against 76.2 for the same-size original SigLIP. That motivated selection, without claiming the latest 2026 model. All runs fit four gigabytes. The encoder converts pixels into features. A new classifier predicts three labels. Frozen training changes only classifier weights. Partial training also updates the final two encoder blocks and normalisation. Each starts from original pretrained weights. We use only images, not text prompts. Both receive 224-pixel images with matching flips and rotations. Two models, two settings and three seeds give twelve runs. Validation selects each checkpoint.</a:t>
             </a:r>
           </a:p>
           <a:p xmlns:a="http://schemas.openxmlformats.org/drawingml/2006/main">
@@ -994,6 +1201,11 @@
           <a:p xmlns:a="http://schemas.openxmlformats.org/drawingml/2006/main">
             <a:r>
               <a:t>src/followup_experiment.py and study_plan.json. SigLIP attention pooling remains frozen with gradient flow.</a:t>
+            </a:r>
+          </a:p>
+          <a:p xmlns:a="http://schemas.openxmlformats.org/drawingml/2006/main">
+            <a:r>
+              <a:t>Selection rationale: Tschannen et al. (2025), Table 1, B/16-224 ImageNet zero-shot SigLIP 2 78.2 vs SigLIP 76.2. This is a published model-selection benchmark, not a Beans result or a latest-2026 claim.</a:t>
             </a:r>
           </a:p>
         </p:txBody>
@@ -3981,12 +4193,12 @@
   </p:cSld>
   <p:clrMap bg1="lt1" tx1="dk1" bg2="lt2" tx2="dk2" accent1="accent1" accent2="accent2" accent3="accent3" accent4="accent4" accent5="accent5" accent6="accent6" hlink="hlink" folHlink="folHlink"/>
   <p:sldLayoutIdLst>
-    <p:sldLayoutId xmlns:r="http://schemas.openxmlformats.org/officeDocument/2006/relationships" id="2147483649" r:id="R75d94c2bf8c544bc"/>
-    <p:sldLayoutId xmlns:r="http://schemas.openxmlformats.org/officeDocument/2006/relationships" id="2147483650" r:id="R42b2192e5d304afa"/>
-    <p:sldLayoutId xmlns:r="http://schemas.openxmlformats.org/officeDocument/2006/relationships" id="2147483651" r:id="Rb8c9bba32ee247be"/>
-    <p:sldLayoutId xmlns:r="http://schemas.openxmlformats.org/officeDocument/2006/relationships" id="2147483652" r:id="Re88d9a3c5f4242d7"/>
-    <p:sldLayoutId xmlns:r="http://schemas.openxmlformats.org/officeDocument/2006/relationships" id="2147483653" r:id="Rc5fdaea29cec45d1"/>
-    <p:sldLayoutId xmlns:r="http://schemas.openxmlformats.org/officeDocument/2006/relationships" id="2147483654" r:id="Reae634cca9154246"/>
+    <p:sldLayoutId xmlns:r="http://schemas.openxmlformats.org/officeDocument/2006/relationships" id="2147483649" r:id="R35feaef3b8c54b62"/>
+    <p:sldLayoutId xmlns:r="http://schemas.openxmlformats.org/officeDocument/2006/relationships" id="2147483650" r:id="R4999c9226dfb404c"/>
+    <p:sldLayoutId xmlns:r="http://schemas.openxmlformats.org/officeDocument/2006/relationships" id="2147483651" r:id="Rb9ee7d21a73f4d79"/>
+    <p:sldLayoutId xmlns:r="http://schemas.openxmlformats.org/officeDocument/2006/relationships" id="2147483652" r:id="Rfeb6ecbb9d1f4b1b"/>
+    <p:sldLayoutId xmlns:r="http://schemas.openxmlformats.org/officeDocument/2006/relationships" id="2147483653" r:id="Rea90fc43e5d24edb"/>
+    <p:sldLayoutId xmlns:r="http://schemas.openxmlformats.org/officeDocument/2006/relationships" id="2147483654" r:id="R3c01e0ca5bb0469f"/>
   </p:sldLayoutIdLst>
   <p:txStyles>
     <p:titleStyle>
@@ -5761,8 +5973,8 @@
         </p:nvSpPr>
         <p:spPr>
           <a:xfrm xmlns:a="http://schemas.openxmlformats.org/drawingml/2006/main">
-            <a:off x="609600" y="4886325"/>
-            <a:ext cx="5619750" cy="723900"/>
+            <a:off x="609600" y="4429125"/>
+            <a:ext cx="6572250" cy="1333500"/>
           </a:xfrm>
           <a:prstGeom xmlns:a="http://schemas.openxmlformats.org/drawingml/2006/main" prst="rect">
             <a:avLst/>
@@ -5778,7 +5990,7 @@
           </a:bodyPr>
           <a:lstStyle xmlns:a="http://schemas.openxmlformats.org/drawingml/2006/main">
             <a:defPPr>
-              <a:defRPr sz="1800" b="0">
+              <a:defRPr sz="1875" b="0">
                 <a:solidFill>
                   <a:srgbClr val="5D6864"/>
                 </a:solidFill>
@@ -5890,7 +6102,7 @@
           <a:p xmlns:a="http://schemas.openxmlformats.org/drawingml/2006/main">
             <a:pPr>
               <a:buNone/>
-              <a:defRPr sz="1800" b="0">
+              <a:defRPr sz="1875" b="0">
                 <a:solidFill>
                   <a:srgbClr val="5D6864"/>
                 </a:solidFill>
@@ -5900,7 +6112,55 @@
               </a:defRPr>
             </a:pPr>
             <a:r>
-              <a:rPr sz="1800" b="0">
+              <a:rPr sz="1875" b="0">
+                <a:solidFill>
+                  <a:srgbClr val="5D6864"/>
+                </a:solidFill>
+                <a:latin typeface="Arial"/>
+                <a:ea typeface="Arial"/>
+                <a:cs typeface="Arial"/>
+              </a:rPr>
+              <a:t>Omar Ahmad Obaid, Student ID 7309429</a:t>
+            </a:r>
+          </a:p>
+          <a:p xmlns:a="http://schemas.openxmlformats.org/drawingml/2006/main">
+            <a:pPr>
+              <a:buNone/>
+              <a:defRPr sz="1875" b="0">
+                <a:solidFill>
+                  <a:srgbClr val="5D6864"/>
+                </a:solidFill>
+                <a:latin typeface="Arial"/>
+                <a:ea typeface="Arial"/>
+                <a:cs typeface="Arial"/>
+              </a:defRPr>
+            </a:pPr>
+            <a:r>
+              <a:rPr sz="1875" b="0">
+                <a:solidFill>
+                  <a:srgbClr val="5D6864"/>
+                </a:solidFill>
+                <a:latin typeface="Arial"/>
+                <a:ea typeface="Arial"/>
+                <a:cs typeface="Arial"/>
+              </a:rPr>
+              <a:t>MAAI901 Deep Learning for Visual Data</a:t>
+            </a:r>
+          </a:p>
+          <a:p xmlns:a="http://schemas.openxmlformats.org/drawingml/2006/main">
+            <a:pPr>
+              <a:buNone/>
+              <a:defRPr sz="1875" b="0">
+                <a:solidFill>
+                  <a:srgbClr val="5D6864"/>
+                </a:solidFill>
+                <a:latin typeface="Arial"/>
+                <a:ea typeface="Arial"/>
+                <a:cs typeface="Arial"/>
+              </a:defRPr>
+            </a:pPr>
+            <a:r>
+              <a:rPr sz="1875" b="0">
                 <a:solidFill>
                   <a:srgbClr val="5D6864"/>
                 </a:solidFill>
@@ -5914,7 +6174,7 @@
           <a:p xmlns:a="http://schemas.openxmlformats.org/drawingml/2006/main">
             <a:pPr>
               <a:buNone/>
-              <a:defRPr sz="1800" b="0">
+              <a:defRPr sz="1875" b="0">
                 <a:solidFill>
                   <a:srgbClr val="5D6864"/>
                 </a:solidFill>
@@ -5924,7 +6184,7 @@
               </a:defRPr>
             </a:pPr>
             <a:r>
-              <a:rPr sz="1800" b="0">
+              <a:rPr sz="1875" b="0">
                 <a:solidFill>
                   <a:srgbClr val="5D6864"/>
                 </a:solidFill>
@@ -5942,7 +6202,7 @@
           <p:cNvPr id="5" name="">
             <a:extLst xmlns:a="http://schemas.openxmlformats.org/drawingml/2006/main">
               <a:ext uri="{FF2B5EF4-FFF2-40B4-BE49-F238E27FC236}">
-                <a16:creationId xmlns:a16="http://schemas.microsoft.com/office/drawing/2014/main" id="{3BD2B07C-9E09-4171-A5C2-5724C98A154B}"/>
+                <a16:creationId xmlns:a16="http://schemas.microsoft.com/office/drawing/2014/main" id="{734E4BF4-AC9D-4DB1-8F2D-2473F7C1C95D}"/>
               </a:ext>
             </a:extLst>
           </p:cNvPr>
@@ -5952,7 +6212,7 @@
           <p:nvPr/>
         </p:nvPicPr>
         <p:blipFill>
-          <a:blip xmlns:r="http://schemas.openxmlformats.org/officeDocument/2006/relationships" xmlns:a="http://schemas.openxmlformats.org/drawingml/2006/main" r:embed="R55e9438a3c214d97"/>
+          <a:blip xmlns:r="http://schemas.openxmlformats.org/officeDocument/2006/relationships" xmlns:a="http://schemas.openxmlformats.org/drawingml/2006/main" r:embed="R88b03ed734aa4387"/>
           <a:stretch xmlns:a="http://schemas.openxmlformats.org/drawingml/2006/main"/>
         </p:blipFill>
         <p:spPr>
@@ -6335,7 +6595,7 @@
           <p:cNvPr id="3" name="">
             <a:extLst xmlns:a="http://schemas.openxmlformats.org/drawingml/2006/main">
               <a:ext uri="{FF2B5EF4-FFF2-40B4-BE49-F238E27FC236}">
-                <a16:creationId xmlns:a16="http://schemas.microsoft.com/office/drawing/2014/main" id="{AF5F6D5F-70D3-4E76-A2D6-F83E3D2A958A}"/>
+                <a16:creationId xmlns:a16="http://schemas.microsoft.com/office/drawing/2014/main" id="{82AE6E38-F717-4D36-9010-5413F978DA0F}"/>
               </a:ext>
             </a:extLst>
           </p:cNvPr>
@@ -7660,7 +7920,7 @@
           <p:cNvPr id="4" name="">
             <a:extLst xmlns:a="http://schemas.openxmlformats.org/drawingml/2006/main">
               <a:ext uri="{FF2B5EF4-FFF2-40B4-BE49-F238E27FC236}">
-                <a16:creationId xmlns:a16="http://schemas.microsoft.com/office/drawing/2014/main" id="{221E64FD-7CF9-4619-9265-2C62E504B390}"/>
+                <a16:creationId xmlns:a16="http://schemas.microsoft.com/office/drawing/2014/main" id="{D917F129-307F-4B79-B1C2-D497BA2ED3C2}"/>
               </a:ext>
             </a:extLst>
           </p:cNvPr>
@@ -8273,6 +8533,2809 @@
       </p:grpSpPr>
       <p:sp>
         <p:nvSpPr>
+          <p:cNvPr id="7" name="">
+            <a:extLst xmlns:a="http://schemas.openxmlformats.org/drawingml/2006/main">
+              <a:ext uri="{FF2B5EF4-FFF2-40B4-BE49-F238E27FC236}">
+                <a16:creationId xmlns:a16="http://schemas.microsoft.com/office/drawing/2014/main" id="{BE9503E9-54C1-4010-814D-72CC7490AC73}"/>
+              </a:ext>
+            </a:extLst>
+          </p:cNvPr>
+          <p:cNvSpPr>
+            <a:spLocks xmlns:a="http://schemas.openxmlformats.org/drawingml/2006/main" noGrp="1"/>
+          </p:cNvSpPr>
+          <p:nvPr/>
+        </p:nvSpPr>
+        <p:spPr>
+          <a:xfrm xmlns:a="http://schemas.openxmlformats.org/drawingml/2006/main">
+            <a:off x="609600" y="400050"/>
+            <a:ext cx="10810875" cy="1028700"/>
+          </a:xfrm>
+          <a:prstGeom xmlns:a="http://schemas.openxmlformats.org/drawingml/2006/main" prst="rect">
+            <a:avLst/>
+          </a:prstGeom>
+          <a:noFill xmlns:a="http://schemas.openxmlformats.org/drawingml/2006/main"/>
+          <a:ln xmlns:a="http://schemas.openxmlformats.org/drawingml/2006/main" w="0">
+            <a:noFill/>
+          </a:ln>
+        </p:spPr>
+        <p:txBody>
+          <a:bodyPr xmlns:a="http://schemas.openxmlformats.org/drawingml/2006/main" wrap="square" lIns="0" tIns="0" rIns="0" bIns="0" anchor="t">
+            <a:noAutofit/>
+          </a:bodyPr>
+          <a:lstStyle xmlns:a="http://schemas.openxmlformats.org/drawingml/2006/main">
+            <a:defPPr>
+              <a:defRPr sz="3300" b="1">
+                <a:solidFill>
+                  <a:srgbClr val="22362F"/>
+                </a:solidFill>
+                <a:latin typeface="Arial"/>
+                <a:ea typeface="Arial"/>
+                <a:cs typeface="Arial"/>
+              </a:defRPr>
+            </a:defPPr>
+            <a:lvl1pPr>
+              <a:buNone/>
+              <a:defRPr sz="3300" b="1">
+                <a:solidFill>
+                  <a:srgbClr val="22362F"/>
+                </a:solidFill>
+                <a:latin typeface="Arial"/>
+                <a:ea typeface="Arial"/>
+                <a:cs typeface="Arial"/>
+              </a:defRPr>
+            </a:lvl1pPr>
+            <a:lvl2pPr>
+              <a:buNone/>
+              <a:defRPr sz="3300" b="1">
+                <a:solidFill>
+                  <a:srgbClr val="22362F"/>
+                </a:solidFill>
+                <a:latin typeface="Arial"/>
+                <a:ea typeface="Arial"/>
+                <a:cs typeface="Arial"/>
+              </a:defRPr>
+            </a:lvl2pPr>
+            <a:lvl3pPr>
+              <a:buNone/>
+              <a:defRPr sz="3300" b="1">
+                <a:solidFill>
+                  <a:srgbClr val="22362F"/>
+                </a:solidFill>
+                <a:latin typeface="Arial"/>
+                <a:ea typeface="Arial"/>
+                <a:cs typeface="Arial"/>
+              </a:defRPr>
+            </a:lvl3pPr>
+            <a:lvl4pPr>
+              <a:buNone/>
+              <a:defRPr sz="3300" b="1">
+                <a:solidFill>
+                  <a:srgbClr val="22362F"/>
+                </a:solidFill>
+                <a:latin typeface="Arial"/>
+                <a:ea typeface="Arial"/>
+                <a:cs typeface="Arial"/>
+              </a:defRPr>
+            </a:lvl4pPr>
+            <a:lvl5pPr>
+              <a:buNone/>
+              <a:defRPr sz="3300" b="1">
+                <a:solidFill>
+                  <a:srgbClr val="22362F"/>
+                </a:solidFill>
+                <a:latin typeface="Arial"/>
+                <a:ea typeface="Arial"/>
+                <a:cs typeface="Arial"/>
+              </a:defRPr>
+            </a:lvl5pPr>
+            <a:lvl6pPr>
+              <a:buNone/>
+              <a:defRPr sz="3300" b="1">
+                <a:solidFill>
+                  <a:srgbClr val="22362F"/>
+                </a:solidFill>
+                <a:latin typeface="Arial"/>
+                <a:ea typeface="Arial"/>
+                <a:cs typeface="Arial"/>
+              </a:defRPr>
+            </a:lvl6pPr>
+            <a:lvl7pPr>
+              <a:buNone/>
+              <a:defRPr sz="3300" b="1">
+                <a:solidFill>
+                  <a:srgbClr val="22362F"/>
+                </a:solidFill>
+                <a:latin typeface="Arial"/>
+                <a:ea typeface="Arial"/>
+                <a:cs typeface="Arial"/>
+              </a:defRPr>
+            </a:lvl7pPr>
+            <a:lvl8pPr>
+              <a:buNone/>
+              <a:defRPr sz="3300" b="1">
+                <a:solidFill>
+                  <a:srgbClr val="22362F"/>
+                </a:solidFill>
+                <a:latin typeface="Arial"/>
+                <a:ea typeface="Arial"/>
+                <a:cs typeface="Arial"/>
+              </a:defRPr>
+            </a:lvl8pPr>
+            <a:lvl9pPr>
+              <a:buNone/>
+              <a:defRPr sz="3300" b="1">
+                <a:solidFill>
+                  <a:srgbClr val="22362F"/>
+                </a:solidFill>
+                <a:latin typeface="Arial"/>
+                <a:ea typeface="Arial"/>
+                <a:cs typeface="Arial"/>
+              </a:defRPr>
+            </a:lvl9pPr>
+          </a:lstStyle>
+          <a:p xmlns:a="http://schemas.openxmlformats.org/drawingml/2006/main">
+            <a:pPr>
+              <a:buNone/>
+              <a:defRPr sz="3300" b="1">
+                <a:solidFill>
+                  <a:srgbClr val="22362F"/>
+                </a:solidFill>
+                <a:latin typeface="Arial"/>
+                <a:ea typeface="Arial"/>
+                <a:cs typeface="Arial"/>
+              </a:defRPr>
+            </a:pPr>
+            <a:r>
+              <a:rPr sz="3300" b="1">
+                <a:solidFill>
+                  <a:srgbClr val="22362F"/>
+                </a:solidFill>
+                <a:latin typeface="Arial"/>
+                <a:ea typeface="Arial"/>
+                <a:cs typeface="Arial"/>
+              </a:rPr>
+              <a:t>Class results and a simple baseline</a:t>
+            </a:r>
+          </a:p>
+        </p:txBody>
+      </p:sp>
+      <p:sp>
+        <p:nvSpPr>
+          <p:cNvPr id="2" name="">
+            <a:extLst xmlns:a="http://schemas.openxmlformats.org/drawingml/2006/main">
+              <a:ext uri="{FF2B5EF4-FFF2-40B4-BE49-F238E27FC236}">
+                <a16:creationId xmlns:a16="http://schemas.microsoft.com/office/drawing/2014/main" id="{BA10B516-B255-4688-BDF8-0749A6486AEC}"/>
+              </a:ext>
+            </a:extLst>
+          </p:cNvPr>
+          <p:cNvSpPr>
+            <a:spLocks xmlns:a="http://schemas.openxmlformats.org/drawingml/2006/main" noGrp="1"/>
+          </p:cNvSpPr>
+          <p:nvPr/>
+        </p:nvSpPr>
+        <p:spPr>
+          <a:xfrm xmlns:a="http://schemas.openxmlformats.org/drawingml/2006/main">
+            <a:off x="11144250" y="6381750"/>
+            <a:ext cx="438150" cy="228600"/>
+          </a:xfrm>
+          <a:prstGeom xmlns:a="http://schemas.openxmlformats.org/drawingml/2006/main" prst="rect">
+            <a:avLst/>
+          </a:prstGeom>
+          <a:noFill xmlns:a="http://schemas.openxmlformats.org/drawingml/2006/main"/>
+          <a:ln xmlns:a="http://schemas.openxmlformats.org/drawingml/2006/main" w="0">
+            <a:noFill/>
+          </a:ln>
+        </p:spPr>
+        <p:txBody>
+          <a:bodyPr xmlns:a="http://schemas.openxmlformats.org/drawingml/2006/main" wrap="square" lIns="0" tIns="0" rIns="0" bIns="0" anchor="t">
+            <a:noAutofit/>
+          </a:bodyPr>
+          <a:lstStyle xmlns:a="http://schemas.openxmlformats.org/drawingml/2006/main">
+            <a:defPPr>
+              <a:defRPr sz="1350" b="0">
+                <a:solidFill>
+                  <a:srgbClr val="5D6864"/>
+                </a:solidFill>
+                <a:latin typeface="Arial"/>
+                <a:ea typeface="Arial"/>
+                <a:cs typeface="Arial"/>
+              </a:defRPr>
+            </a:defPPr>
+            <a:lvl1pPr>
+              <a:buNone/>
+              <a:defRPr sz="1350" b="0">
+                <a:solidFill>
+                  <a:srgbClr val="5D6864"/>
+                </a:solidFill>
+                <a:latin typeface="Arial"/>
+                <a:ea typeface="Arial"/>
+                <a:cs typeface="Arial"/>
+              </a:defRPr>
+            </a:lvl1pPr>
+            <a:lvl2pPr>
+              <a:buNone/>
+              <a:defRPr sz="1350" b="0">
+                <a:solidFill>
+                  <a:srgbClr val="5D6864"/>
+                </a:solidFill>
+                <a:latin typeface="Arial"/>
+                <a:ea typeface="Arial"/>
+                <a:cs typeface="Arial"/>
+              </a:defRPr>
+            </a:lvl2pPr>
+            <a:lvl3pPr>
+              <a:buNone/>
+              <a:defRPr sz="1350" b="0">
+                <a:solidFill>
+                  <a:srgbClr val="5D6864"/>
+                </a:solidFill>
+                <a:latin typeface="Arial"/>
+                <a:ea typeface="Arial"/>
+                <a:cs typeface="Arial"/>
+              </a:defRPr>
+            </a:lvl3pPr>
+            <a:lvl4pPr>
+              <a:buNone/>
+              <a:defRPr sz="1350" b="0">
+                <a:solidFill>
+                  <a:srgbClr val="5D6864"/>
+                </a:solidFill>
+                <a:latin typeface="Arial"/>
+                <a:ea typeface="Arial"/>
+                <a:cs typeface="Arial"/>
+              </a:defRPr>
+            </a:lvl4pPr>
+            <a:lvl5pPr>
+              <a:buNone/>
+              <a:defRPr sz="1350" b="0">
+                <a:solidFill>
+                  <a:srgbClr val="5D6864"/>
+                </a:solidFill>
+                <a:latin typeface="Arial"/>
+                <a:ea typeface="Arial"/>
+                <a:cs typeface="Arial"/>
+              </a:defRPr>
+            </a:lvl5pPr>
+            <a:lvl6pPr>
+              <a:buNone/>
+              <a:defRPr sz="1350" b="0">
+                <a:solidFill>
+                  <a:srgbClr val="5D6864"/>
+                </a:solidFill>
+                <a:latin typeface="Arial"/>
+                <a:ea typeface="Arial"/>
+                <a:cs typeface="Arial"/>
+              </a:defRPr>
+            </a:lvl6pPr>
+            <a:lvl7pPr>
+              <a:buNone/>
+              <a:defRPr sz="1350" b="0">
+                <a:solidFill>
+                  <a:srgbClr val="5D6864"/>
+                </a:solidFill>
+                <a:latin typeface="Arial"/>
+                <a:ea typeface="Arial"/>
+                <a:cs typeface="Arial"/>
+              </a:defRPr>
+            </a:lvl7pPr>
+            <a:lvl8pPr>
+              <a:buNone/>
+              <a:defRPr sz="1350" b="0">
+                <a:solidFill>
+                  <a:srgbClr val="5D6864"/>
+                </a:solidFill>
+                <a:latin typeface="Arial"/>
+                <a:ea typeface="Arial"/>
+                <a:cs typeface="Arial"/>
+              </a:defRPr>
+            </a:lvl8pPr>
+            <a:lvl9pPr>
+              <a:buNone/>
+              <a:defRPr sz="1350" b="0">
+                <a:solidFill>
+                  <a:srgbClr val="5D6864"/>
+                </a:solidFill>
+                <a:latin typeface="Arial"/>
+                <a:ea typeface="Arial"/>
+                <a:cs typeface="Arial"/>
+              </a:defRPr>
+            </a:lvl9pPr>
+          </a:lstStyle>
+          <a:p xmlns:a="http://schemas.openxmlformats.org/drawingml/2006/main">
+            <a:pPr>
+              <a:buNone/>
+              <a:defRPr sz="1350" b="0">
+                <a:solidFill>
+                  <a:srgbClr val="5D6864"/>
+                </a:solidFill>
+                <a:latin typeface="Arial"/>
+                <a:ea typeface="Arial"/>
+                <a:cs typeface="Arial"/>
+              </a:defRPr>
+            </a:pPr>
+            <a:r>
+              <a:rPr sz="1350" b="0">
+                <a:solidFill>
+                  <a:srgbClr val="5D6864"/>
+                </a:solidFill>
+                <a:latin typeface="Arial"/>
+                <a:ea typeface="Arial"/>
+                <a:cs typeface="Arial"/>
+              </a:rPr>
+              <a:t>12</a:t>
+            </a:r>
+          </a:p>
+        </p:txBody>
+      </p:sp>
+      <p:sp>
+        <p:nvSpPr>
+          <p:cNvPr id="3" name="">
+            <a:extLst xmlns:a="http://schemas.openxmlformats.org/drawingml/2006/main">
+              <a:ext uri="{FF2B5EF4-FFF2-40B4-BE49-F238E27FC236}">
+                <a16:creationId xmlns:a16="http://schemas.microsoft.com/office/drawing/2014/main" id="{CF70DC2E-1A14-45C4-B977-F39FF2D83546}"/>
+              </a:ext>
+            </a:extLst>
+          </p:cNvPr>
+          <p:cNvSpPr>
+            <a:spLocks xmlns:a="http://schemas.openxmlformats.org/drawingml/2006/main" noGrp="1"/>
+          </p:cNvSpPr>
+          <p:nvPr/>
+        </p:nvSpPr>
+        <p:spPr>
+          <a:xfrm xmlns:a="http://schemas.openxmlformats.org/drawingml/2006/main">
+            <a:off x="609600" y="1066800"/>
+            <a:ext cx="10972800" cy="323850"/>
+          </a:xfrm>
+          <a:prstGeom xmlns:a="http://schemas.openxmlformats.org/drawingml/2006/main" prst="rect">
+            <a:avLst/>
+          </a:prstGeom>
+          <a:noFill xmlns:a="http://schemas.openxmlformats.org/drawingml/2006/main"/>
+          <a:ln xmlns:a="http://schemas.openxmlformats.org/drawingml/2006/main" w="0">
+            <a:noFill/>
+          </a:ln>
+        </p:spPr>
+        <p:txBody>
+          <a:bodyPr xmlns:a="http://schemas.openxmlformats.org/drawingml/2006/main" wrap="square" lIns="0" tIns="0" rIns="0" bIns="0" anchor="t">
+            <a:noAutofit/>
+          </a:bodyPr>
+          <a:lstStyle xmlns:a="http://schemas.openxmlformats.org/drawingml/2006/main">
+            <a:defPPr>
+              <a:defRPr sz="1875" b="0">
+                <a:solidFill>
+                  <a:srgbClr val="5D6864"/>
+                </a:solidFill>
+                <a:latin typeface="Arial"/>
+                <a:ea typeface="Arial"/>
+                <a:cs typeface="Arial"/>
+              </a:defRPr>
+            </a:defPPr>
+            <a:lvl1pPr>
+              <a:buNone/>
+              <a:defRPr sz="1875" b="0">
+                <a:solidFill>
+                  <a:srgbClr val="5D6864"/>
+                </a:solidFill>
+                <a:latin typeface="Arial"/>
+                <a:ea typeface="Arial"/>
+                <a:cs typeface="Arial"/>
+              </a:defRPr>
+            </a:lvl1pPr>
+            <a:lvl2pPr>
+              <a:buNone/>
+              <a:defRPr sz="1875" b="0">
+                <a:solidFill>
+                  <a:srgbClr val="5D6864"/>
+                </a:solidFill>
+                <a:latin typeface="Arial"/>
+                <a:ea typeface="Arial"/>
+                <a:cs typeface="Arial"/>
+              </a:defRPr>
+            </a:lvl2pPr>
+            <a:lvl3pPr>
+              <a:buNone/>
+              <a:defRPr sz="1875" b="0">
+                <a:solidFill>
+                  <a:srgbClr val="5D6864"/>
+                </a:solidFill>
+                <a:latin typeface="Arial"/>
+                <a:ea typeface="Arial"/>
+                <a:cs typeface="Arial"/>
+              </a:defRPr>
+            </a:lvl3pPr>
+            <a:lvl4pPr>
+              <a:buNone/>
+              <a:defRPr sz="1875" b="0">
+                <a:solidFill>
+                  <a:srgbClr val="5D6864"/>
+                </a:solidFill>
+                <a:latin typeface="Arial"/>
+                <a:ea typeface="Arial"/>
+                <a:cs typeface="Arial"/>
+              </a:defRPr>
+            </a:lvl4pPr>
+            <a:lvl5pPr>
+              <a:buNone/>
+              <a:defRPr sz="1875" b="0">
+                <a:solidFill>
+                  <a:srgbClr val="5D6864"/>
+                </a:solidFill>
+                <a:latin typeface="Arial"/>
+                <a:ea typeface="Arial"/>
+                <a:cs typeface="Arial"/>
+              </a:defRPr>
+            </a:lvl5pPr>
+            <a:lvl6pPr>
+              <a:buNone/>
+              <a:defRPr sz="1875" b="0">
+                <a:solidFill>
+                  <a:srgbClr val="5D6864"/>
+                </a:solidFill>
+                <a:latin typeface="Arial"/>
+                <a:ea typeface="Arial"/>
+                <a:cs typeface="Arial"/>
+              </a:defRPr>
+            </a:lvl6pPr>
+            <a:lvl7pPr>
+              <a:buNone/>
+              <a:defRPr sz="1875" b="0">
+                <a:solidFill>
+                  <a:srgbClr val="5D6864"/>
+                </a:solidFill>
+                <a:latin typeface="Arial"/>
+                <a:ea typeface="Arial"/>
+                <a:cs typeface="Arial"/>
+              </a:defRPr>
+            </a:lvl7pPr>
+            <a:lvl8pPr>
+              <a:buNone/>
+              <a:defRPr sz="1875" b="0">
+                <a:solidFill>
+                  <a:srgbClr val="5D6864"/>
+                </a:solidFill>
+                <a:latin typeface="Arial"/>
+                <a:ea typeface="Arial"/>
+                <a:cs typeface="Arial"/>
+              </a:defRPr>
+            </a:lvl8pPr>
+            <a:lvl9pPr>
+              <a:buNone/>
+              <a:defRPr sz="1875" b="0">
+                <a:solidFill>
+                  <a:srgbClr val="5D6864"/>
+                </a:solidFill>
+                <a:latin typeface="Arial"/>
+                <a:ea typeface="Arial"/>
+                <a:cs typeface="Arial"/>
+              </a:defRPr>
+            </a:lvl9pPr>
+          </a:lstStyle>
+          <a:p xmlns:a="http://schemas.openxmlformats.org/drawingml/2006/main">
+            <a:pPr>
+              <a:buNone/>
+              <a:defRPr sz="1875" b="0">
+                <a:solidFill>
+                  <a:srgbClr val="5D6864"/>
+                </a:solidFill>
+                <a:latin typeface="Arial"/>
+                <a:ea typeface="Arial"/>
+                <a:cs typeface="Arial"/>
+              </a:defRPr>
+            </a:pPr>
+            <a:r>
+              <a:rPr sz="1875" b="0">
+                <a:solidFill>
+                  <a:srgbClr val="5D6864"/>
+                </a:solidFill>
+                <a:latin typeface="Arial"/>
+                <a:ea typeface="Arial"/>
+                <a:cs typeface="Arial"/>
+              </a:rPr>
+              <a:t>Partial fine-tuning, reference seed 17, 128 test images</a:t>
+            </a:r>
+          </a:p>
+        </p:txBody>
+      </p:sp>
+      <p:graphicFrame>
+        <p:nvGraphicFramePr>
+          <p:cNvPr id="4" name="">
+            <a:extLst xmlns:a="http://schemas.openxmlformats.org/drawingml/2006/main">
+              <a:ext uri="{FF2B5EF4-FFF2-40B4-BE49-F238E27FC236}">
+                <a16:creationId xmlns:a16="http://schemas.microsoft.com/office/drawing/2014/main" id="{B61C1CC7-DB51-4984-A754-7866FAA2EF29}"/>
+              </a:ext>
+            </a:extLst>
+          </p:cNvPr>
+          <p:cNvGraphicFramePr/>
+          <p:nvPr/>
+        </p:nvGraphicFramePr>
+        <p:xfrm>
+          <a:off xmlns:a="http://schemas.openxmlformats.org/drawingml/2006/main" x="609600" y="1571625"/>
+          <a:ext xmlns:a="http://schemas.openxmlformats.org/drawingml/2006/main" cx="10972800" cy="3600450"/>
+        </p:xfrm>
+        <a:graphic xmlns:a="http://schemas.openxmlformats.org/drawingml/2006/main">
+          <a:graphicData uri="http://schemas.openxmlformats.org/drawingml/2006/table">
+            <a:tbl>
+              <a:tblPr/>
+              <a:tblGrid>
+                <a:gridCol w="4572000"/>
+                <a:gridCol w="2133600"/>
+                <a:gridCol w="2133600"/>
+                <a:gridCol w="2133600"/>
+              </a:tblGrid>
+              <a:tr h="514350">
+                <a:tc>
+                  <a:txBody>
+                    <a:bodyPr lIns="114300" tIns="114300" rIns="114300" bIns="114300"/>
+                    <a:lstStyle/>
+                    <a:p>
+                      <a:r>
+                        <a:rPr sz="1800" b="1">
+                          <a:solidFill>
+                            <a:srgbClr val="22362F"/>
+                          </a:solidFill>
+                          <a:latin typeface="Arial"/>
+                          <a:ea typeface="Arial"/>
+                          <a:cs typeface="Arial"/>
+                        </a:rPr>
+                        <a:t>Model / class</a:t>
+                      </a:r>
+                    </a:p>
+                  </a:txBody>
+                  <a:tcPr marL="91440" marR="91440" marT="45720" marB="45720" anchor="ctr">
+                    <a:solidFill>
+                      <a:srgbClr val="E8EEEB"/>
+                    </a:solidFill>
+                  </a:tcPr>
+                </a:tc>
+                <a:tc>
+                  <a:txBody>
+                    <a:bodyPr lIns="114300" tIns="114300" rIns="114300" bIns="114300"/>
+                    <a:lstStyle/>
+                    <a:p>
+                      <a:r>
+                        <a:rPr sz="1800" b="1">
+                          <a:solidFill>
+                            <a:srgbClr val="22362F"/>
+                          </a:solidFill>
+                          <a:latin typeface="Arial"/>
+                          <a:ea typeface="Arial"/>
+                          <a:cs typeface="Arial"/>
+                        </a:rPr>
+                        <a:t>Precision (%)</a:t>
+                      </a:r>
+                    </a:p>
+                  </a:txBody>
+                  <a:tcPr marL="91440" marR="91440" marT="45720" marB="45720" anchor="ctr">
+                    <a:solidFill>
+                      <a:srgbClr val="E8EEEB"/>
+                    </a:solidFill>
+                  </a:tcPr>
+                </a:tc>
+                <a:tc>
+                  <a:txBody>
+                    <a:bodyPr lIns="114300" tIns="114300" rIns="114300" bIns="114300"/>
+                    <a:lstStyle/>
+                    <a:p>
+                      <a:r>
+                        <a:rPr sz="1800" b="1">
+                          <a:solidFill>
+                            <a:srgbClr val="22362F"/>
+                          </a:solidFill>
+                          <a:latin typeface="Arial"/>
+                          <a:ea typeface="Arial"/>
+                          <a:cs typeface="Arial"/>
+                        </a:rPr>
+                        <a:t>Recall (%)</a:t>
+                      </a:r>
+                    </a:p>
+                  </a:txBody>
+                  <a:tcPr marL="91440" marR="91440" marT="45720" marB="45720" anchor="ctr">
+                    <a:solidFill>
+                      <a:srgbClr val="E8EEEB"/>
+                    </a:solidFill>
+                  </a:tcPr>
+                </a:tc>
+                <a:tc>
+                  <a:txBody>
+                    <a:bodyPr lIns="114300" tIns="114300" rIns="114300" bIns="114300"/>
+                    <a:lstStyle/>
+                    <a:p>
+                      <a:r>
+                        <a:rPr sz="1800" b="1">
+                          <a:solidFill>
+                            <a:srgbClr val="22362F"/>
+                          </a:solidFill>
+                          <a:latin typeface="Arial"/>
+                          <a:ea typeface="Arial"/>
+                          <a:cs typeface="Arial"/>
+                        </a:rPr>
+                        <a:t>F1 (%)</a:t>
+                      </a:r>
+                    </a:p>
+                  </a:txBody>
+                  <a:tcPr marL="91440" marR="91440" marT="45720" marB="45720" anchor="ctr">
+                    <a:solidFill>
+                      <a:srgbClr val="E8EEEB"/>
+                    </a:solidFill>
+                  </a:tcPr>
+                </a:tc>
+              </a:tr>
+              <a:tr h="514350">
+                <a:tc>
+                  <a:txBody>
+                    <a:bodyPr lIns="114300" tIns="114300" rIns="114300" bIns="114300"/>
+                    <a:lstStyle/>
+                    <a:p>
+                      <a:r>
+                        <a:rPr sz="1800" b="0">
+                          <a:solidFill>
+                            <a:srgbClr val="22362F"/>
+                          </a:solidFill>
+                          <a:latin typeface="Arial"/>
+                          <a:ea typeface="Arial"/>
+                          <a:cs typeface="Arial"/>
+                        </a:rPr>
+                        <a:t>DINOv2: Angular leaf spot</a:t>
+                      </a:r>
+                    </a:p>
+                  </a:txBody>
+                  <a:tcPr marL="91440" marR="91440" marT="45720" marB="45720" anchor="ctr">
+                    <a:solidFill>
+                      <a:srgbClr val="FFFFFF"/>
+                    </a:solidFill>
+                  </a:tcPr>
+                </a:tc>
+                <a:tc>
+                  <a:txBody>
+                    <a:bodyPr lIns="114300" tIns="114300" rIns="114300" bIns="114300"/>
+                    <a:lstStyle/>
+                    <a:p>
+                      <a:r>
+                        <a:rPr sz="1800" b="0">
+                          <a:solidFill>
+                            <a:srgbClr val="22362F"/>
+                          </a:solidFill>
+                          <a:latin typeface="Arial"/>
+                          <a:ea typeface="Arial"/>
+                          <a:cs typeface="Arial"/>
+                        </a:rPr>
+                        <a:t>100.00</a:t>
+                      </a:r>
+                    </a:p>
+                  </a:txBody>
+                  <a:tcPr marL="91440" marR="91440" marT="45720" marB="45720" anchor="ctr">
+                    <a:solidFill>
+                      <a:srgbClr val="FFFFFF"/>
+                    </a:solidFill>
+                  </a:tcPr>
+                </a:tc>
+                <a:tc>
+                  <a:txBody>
+                    <a:bodyPr lIns="114300" tIns="114300" rIns="114300" bIns="114300"/>
+                    <a:lstStyle/>
+                    <a:p>
+                      <a:r>
+                        <a:rPr sz="1800" b="0">
+                          <a:solidFill>
+                            <a:srgbClr val="22362F"/>
+                          </a:solidFill>
+                          <a:latin typeface="Arial"/>
+                          <a:ea typeface="Arial"/>
+                          <a:cs typeface="Arial"/>
+                        </a:rPr>
+                        <a:t>97.67</a:t>
+                      </a:r>
+                    </a:p>
+                  </a:txBody>
+                  <a:tcPr marL="91440" marR="91440" marT="45720" marB="45720" anchor="ctr">
+                    <a:solidFill>
+                      <a:srgbClr val="FFFFFF"/>
+                    </a:solidFill>
+                  </a:tcPr>
+                </a:tc>
+                <a:tc>
+                  <a:txBody>
+                    <a:bodyPr lIns="114300" tIns="114300" rIns="114300" bIns="114300"/>
+                    <a:lstStyle/>
+                    <a:p>
+                      <a:r>
+                        <a:rPr sz="1800" b="0">
+                          <a:solidFill>
+                            <a:srgbClr val="22362F"/>
+                          </a:solidFill>
+                          <a:latin typeface="Arial"/>
+                          <a:ea typeface="Arial"/>
+                          <a:cs typeface="Arial"/>
+                        </a:rPr>
+                        <a:t>98.82</a:t>
+                      </a:r>
+                    </a:p>
+                  </a:txBody>
+                  <a:tcPr marL="91440" marR="91440" marT="45720" marB="45720" anchor="ctr">
+                    <a:solidFill>
+                      <a:srgbClr val="FFFFFF"/>
+                    </a:solidFill>
+                  </a:tcPr>
+                </a:tc>
+              </a:tr>
+              <a:tr h="514350">
+                <a:tc>
+                  <a:txBody>
+                    <a:bodyPr lIns="114300" tIns="114300" rIns="114300" bIns="114300"/>
+                    <a:lstStyle/>
+                    <a:p>
+                      <a:r>
+                        <a:rPr sz="1800" b="0">
+                          <a:solidFill>
+                            <a:srgbClr val="22362F"/>
+                          </a:solidFill>
+                          <a:latin typeface="Arial"/>
+                          <a:ea typeface="Arial"/>
+                          <a:cs typeface="Arial"/>
+                        </a:rPr>
+                        <a:t>DINOv2: Bean rust</a:t>
+                      </a:r>
+                    </a:p>
+                  </a:txBody>
+                  <a:tcPr marL="91440" marR="91440" marT="45720" marB="45720" anchor="ctr">
+                    <a:solidFill>
+                      <a:srgbClr val="FFFFFF"/>
+                    </a:solidFill>
+                  </a:tcPr>
+                </a:tc>
+                <a:tc>
+                  <a:txBody>
+                    <a:bodyPr lIns="114300" tIns="114300" rIns="114300" bIns="114300"/>
+                    <a:lstStyle/>
+                    <a:p>
+                      <a:r>
+                        <a:rPr sz="1800" b="0">
+                          <a:solidFill>
+                            <a:srgbClr val="22362F"/>
+                          </a:solidFill>
+                          <a:latin typeface="Arial"/>
+                          <a:ea typeface="Arial"/>
+                          <a:cs typeface="Arial"/>
+                        </a:rPr>
+                        <a:t>95.56</a:t>
+                      </a:r>
+                    </a:p>
+                  </a:txBody>
+                  <a:tcPr marL="91440" marR="91440" marT="45720" marB="45720" anchor="ctr">
+                    <a:solidFill>
+                      <a:srgbClr val="FFFFFF"/>
+                    </a:solidFill>
+                  </a:tcPr>
+                </a:tc>
+                <a:tc>
+                  <a:txBody>
+                    <a:bodyPr lIns="114300" tIns="114300" rIns="114300" bIns="114300"/>
+                    <a:lstStyle/>
+                    <a:p>
+                      <a:r>
+                        <a:rPr sz="1800" b="0">
+                          <a:solidFill>
+                            <a:srgbClr val="22362F"/>
+                          </a:solidFill>
+                          <a:latin typeface="Arial"/>
+                          <a:ea typeface="Arial"/>
+                          <a:cs typeface="Arial"/>
+                        </a:rPr>
+                        <a:t>100.00</a:t>
+                      </a:r>
+                    </a:p>
+                  </a:txBody>
+                  <a:tcPr marL="91440" marR="91440" marT="45720" marB="45720" anchor="ctr">
+                    <a:solidFill>
+                      <a:srgbClr val="FFFFFF"/>
+                    </a:solidFill>
+                  </a:tcPr>
+                </a:tc>
+                <a:tc>
+                  <a:txBody>
+                    <a:bodyPr lIns="114300" tIns="114300" rIns="114300" bIns="114300"/>
+                    <a:lstStyle/>
+                    <a:p>
+                      <a:r>
+                        <a:rPr sz="1800" b="0">
+                          <a:solidFill>
+                            <a:srgbClr val="22362F"/>
+                          </a:solidFill>
+                          <a:latin typeface="Arial"/>
+                          <a:ea typeface="Arial"/>
+                          <a:cs typeface="Arial"/>
+                        </a:rPr>
+                        <a:t>97.73</a:t>
+                      </a:r>
+                    </a:p>
+                  </a:txBody>
+                  <a:tcPr marL="91440" marR="91440" marT="45720" marB="45720" anchor="ctr">
+                    <a:solidFill>
+                      <a:srgbClr val="FFFFFF"/>
+                    </a:solidFill>
+                  </a:tcPr>
+                </a:tc>
+              </a:tr>
+              <a:tr h="514350">
+                <a:tc>
+                  <a:txBody>
+                    <a:bodyPr lIns="114300" tIns="114300" rIns="114300" bIns="114300"/>
+                    <a:lstStyle/>
+                    <a:p>
+                      <a:r>
+                        <a:rPr sz="1800" b="0">
+                          <a:solidFill>
+                            <a:srgbClr val="22362F"/>
+                          </a:solidFill>
+                          <a:latin typeface="Arial"/>
+                          <a:ea typeface="Arial"/>
+                          <a:cs typeface="Arial"/>
+                        </a:rPr>
+                        <a:t>DINOv2: Healthy</a:t>
+                      </a:r>
+                    </a:p>
+                  </a:txBody>
+                  <a:tcPr marL="91440" marR="91440" marT="45720" marB="45720" anchor="ctr">
+                    <a:solidFill>
+                      <a:srgbClr val="FFFFFF"/>
+                    </a:solidFill>
+                  </a:tcPr>
+                </a:tc>
+                <a:tc>
+                  <a:txBody>
+                    <a:bodyPr lIns="114300" tIns="114300" rIns="114300" bIns="114300"/>
+                    <a:lstStyle/>
+                    <a:p>
+                      <a:r>
+                        <a:rPr sz="1800" b="0">
+                          <a:solidFill>
+                            <a:srgbClr val="22362F"/>
+                          </a:solidFill>
+                          <a:latin typeface="Arial"/>
+                          <a:ea typeface="Arial"/>
+                          <a:cs typeface="Arial"/>
+                        </a:rPr>
+                        <a:t>100.00</a:t>
+                      </a:r>
+                    </a:p>
+                  </a:txBody>
+                  <a:tcPr marL="91440" marR="91440" marT="45720" marB="45720" anchor="ctr">
+                    <a:solidFill>
+                      <a:srgbClr val="FFFFFF"/>
+                    </a:solidFill>
+                  </a:tcPr>
+                </a:tc>
+                <a:tc>
+                  <a:txBody>
+                    <a:bodyPr lIns="114300" tIns="114300" rIns="114300" bIns="114300"/>
+                    <a:lstStyle/>
+                    <a:p>
+                      <a:r>
+                        <a:rPr sz="1800" b="0">
+                          <a:solidFill>
+                            <a:srgbClr val="22362F"/>
+                          </a:solidFill>
+                          <a:latin typeface="Arial"/>
+                          <a:ea typeface="Arial"/>
+                          <a:cs typeface="Arial"/>
+                        </a:rPr>
+                        <a:t>97.62</a:t>
+                      </a:r>
+                    </a:p>
+                  </a:txBody>
+                  <a:tcPr marL="91440" marR="91440" marT="45720" marB="45720" anchor="ctr">
+                    <a:solidFill>
+                      <a:srgbClr val="FFFFFF"/>
+                    </a:solidFill>
+                  </a:tcPr>
+                </a:tc>
+                <a:tc>
+                  <a:txBody>
+                    <a:bodyPr lIns="114300" tIns="114300" rIns="114300" bIns="114300"/>
+                    <a:lstStyle/>
+                    <a:p>
+                      <a:r>
+                        <a:rPr sz="1800" b="0">
+                          <a:solidFill>
+                            <a:srgbClr val="22362F"/>
+                          </a:solidFill>
+                          <a:latin typeface="Arial"/>
+                          <a:ea typeface="Arial"/>
+                          <a:cs typeface="Arial"/>
+                        </a:rPr>
+                        <a:t>98.80</a:t>
+                      </a:r>
+                    </a:p>
+                  </a:txBody>
+                  <a:tcPr marL="91440" marR="91440" marT="45720" marB="45720" anchor="ctr">
+                    <a:solidFill>
+                      <a:srgbClr val="FFFFFF"/>
+                    </a:solidFill>
+                  </a:tcPr>
+                </a:tc>
+              </a:tr>
+              <a:tr h="514350">
+                <a:tc>
+                  <a:txBody>
+                    <a:bodyPr lIns="114300" tIns="114300" rIns="114300" bIns="114300"/>
+                    <a:lstStyle/>
+                    <a:p>
+                      <a:r>
+                        <a:rPr sz="1800" b="0">
+                          <a:solidFill>
+                            <a:srgbClr val="22362F"/>
+                          </a:solidFill>
+                          <a:latin typeface="Arial"/>
+                          <a:ea typeface="Arial"/>
+                          <a:cs typeface="Arial"/>
+                        </a:rPr>
+                        <a:t>SigLIP 2: Angular leaf spot</a:t>
+                      </a:r>
+                    </a:p>
+                  </a:txBody>
+                  <a:tcPr marL="91440" marR="91440" marT="45720" marB="45720" anchor="ctr">
+                    <a:solidFill>
+                      <a:srgbClr val="FFFFFF"/>
+                    </a:solidFill>
+                  </a:tcPr>
+                </a:tc>
+                <a:tc>
+                  <a:txBody>
+                    <a:bodyPr lIns="114300" tIns="114300" rIns="114300" bIns="114300"/>
+                    <a:lstStyle/>
+                    <a:p>
+                      <a:r>
+                        <a:rPr sz="1800" b="0">
+                          <a:solidFill>
+                            <a:srgbClr val="22362F"/>
+                          </a:solidFill>
+                          <a:latin typeface="Arial"/>
+                          <a:ea typeface="Arial"/>
+                          <a:cs typeface="Arial"/>
+                        </a:rPr>
+                        <a:t>100.00</a:t>
+                      </a:r>
+                    </a:p>
+                  </a:txBody>
+                  <a:tcPr marL="91440" marR="91440" marT="45720" marB="45720" anchor="ctr">
+                    <a:solidFill>
+                      <a:srgbClr val="FFFFFF"/>
+                    </a:solidFill>
+                  </a:tcPr>
+                </a:tc>
+                <a:tc>
+                  <a:txBody>
+                    <a:bodyPr lIns="114300" tIns="114300" rIns="114300" bIns="114300"/>
+                    <a:lstStyle/>
+                    <a:p>
+                      <a:r>
+                        <a:rPr sz="1800" b="0">
+                          <a:solidFill>
+                            <a:srgbClr val="22362F"/>
+                          </a:solidFill>
+                          <a:latin typeface="Arial"/>
+                          <a:ea typeface="Arial"/>
+                          <a:cs typeface="Arial"/>
+                        </a:rPr>
+                        <a:t>93.02</a:t>
+                      </a:r>
+                    </a:p>
+                  </a:txBody>
+                  <a:tcPr marL="91440" marR="91440" marT="45720" marB="45720" anchor="ctr">
+                    <a:solidFill>
+                      <a:srgbClr val="FFFFFF"/>
+                    </a:solidFill>
+                  </a:tcPr>
+                </a:tc>
+                <a:tc>
+                  <a:txBody>
+                    <a:bodyPr lIns="114300" tIns="114300" rIns="114300" bIns="114300"/>
+                    <a:lstStyle/>
+                    <a:p>
+                      <a:r>
+                        <a:rPr sz="1800" b="0">
+                          <a:solidFill>
+                            <a:srgbClr val="22362F"/>
+                          </a:solidFill>
+                          <a:latin typeface="Arial"/>
+                          <a:ea typeface="Arial"/>
+                          <a:cs typeface="Arial"/>
+                        </a:rPr>
+                        <a:t>96.39</a:t>
+                      </a:r>
+                    </a:p>
+                  </a:txBody>
+                  <a:tcPr marL="91440" marR="91440" marT="45720" marB="45720" anchor="ctr">
+                    <a:solidFill>
+                      <a:srgbClr val="FFFFFF"/>
+                    </a:solidFill>
+                  </a:tcPr>
+                </a:tc>
+              </a:tr>
+              <a:tr h="514350">
+                <a:tc>
+                  <a:txBody>
+                    <a:bodyPr lIns="114300" tIns="114300" rIns="114300" bIns="114300"/>
+                    <a:lstStyle/>
+                    <a:p>
+                      <a:r>
+                        <a:rPr sz="1800" b="0">
+                          <a:solidFill>
+                            <a:srgbClr val="22362F"/>
+                          </a:solidFill>
+                          <a:latin typeface="Arial"/>
+                          <a:ea typeface="Arial"/>
+                          <a:cs typeface="Arial"/>
+                        </a:rPr>
+                        <a:t>SigLIP 2: Bean rust</a:t>
+                      </a:r>
+                    </a:p>
+                  </a:txBody>
+                  <a:tcPr marL="91440" marR="91440" marT="45720" marB="45720" anchor="ctr">
+                    <a:solidFill>
+                      <a:srgbClr val="FFFFFF"/>
+                    </a:solidFill>
+                  </a:tcPr>
+                </a:tc>
+                <a:tc>
+                  <a:txBody>
+                    <a:bodyPr lIns="114300" tIns="114300" rIns="114300" bIns="114300"/>
+                    <a:lstStyle/>
+                    <a:p>
+                      <a:r>
+                        <a:rPr sz="1800" b="0">
+                          <a:solidFill>
+                            <a:srgbClr val="22362F"/>
+                          </a:solidFill>
+                          <a:latin typeface="Arial"/>
+                          <a:ea typeface="Arial"/>
+                          <a:cs typeface="Arial"/>
+                        </a:rPr>
+                        <a:t>93.48</a:t>
+                      </a:r>
+                    </a:p>
+                  </a:txBody>
+                  <a:tcPr marL="91440" marR="91440" marT="45720" marB="45720" anchor="ctr">
+                    <a:solidFill>
+                      <a:srgbClr val="FFFFFF"/>
+                    </a:solidFill>
+                  </a:tcPr>
+                </a:tc>
+                <a:tc>
+                  <a:txBody>
+                    <a:bodyPr lIns="114300" tIns="114300" rIns="114300" bIns="114300"/>
+                    <a:lstStyle/>
+                    <a:p>
+                      <a:r>
+                        <a:rPr sz="1800" b="0">
+                          <a:solidFill>
+                            <a:srgbClr val="22362F"/>
+                          </a:solidFill>
+                          <a:latin typeface="Arial"/>
+                          <a:ea typeface="Arial"/>
+                          <a:cs typeface="Arial"/>
+                        </a:rPr>
+                        <a:t>100.00</a:t>
+                      </a:r>
+                    </a:p>
+                  </a:txBody>
+                  <a:tcPr marL="91440" marR="91440" marT="45720" marB="45720" anchor="ctr">
+                    <a:solidFill>
+                      <a:srgbClr val="FFFFFF"/>
+                    </a:solidFill>
+                  </a:tcPr>
+                </a:tc>
+                <a:tc>
+                  <a:txBody>
+                    <a:bodyPr lIns="114300" tIns="114300" rIns="114300" bIns="114300"/>
+                    <a:lstStyle/>
+                    <a:p>
+                      <a:r>
+                        <a:rPr sz="1800" b="0">
+                          <a:solidFill>
+                            <a:srgbClr val="22362F"/>
+                          </a:solidFill>
+                          <a:latin typeface="Arial"/>
+                          <a:ea typeface="Arial"/>
+                          <a:cs typeface="Arial"/>
+                        </a:rPr>
+                        <a:t>96.63</a:t>
+                      </a:r>
+                    </a:p>
+                  </a:txBody>
+                  <a:tcPr marL="91440" marR="91440" marT="45720" marB="45720" anchor="ctr">
+                    <a:solidFill>
+                      <a:srgbClr val="FFFFFF"/>
+                    </a:solidFill>
+                  </a:tcPr>
+                </a:tc>
+              </a:tr>
+              <a:tr h="514350">
+                <a:tc>
+                  <a:txBody>
+                    <a:bodyPr lIns="114300" tIns="114300" rIns="114300" bIns="114300"/>
+                    <a:lstStyle/>
+                    <a:p>
+                      <a:r>
+                        <a:rPr sz="1800" b="0">
+                          <a:solidFill>
+                            <a:srgbClr val="22362F"/>
+                          </a:solidFill>
+                          <a:latin typeface="Arial"/>
+                          <a:ea typeface="Arial"/>
+                          <a:cs typeface="Arial"/>
+                        </a:rPr>
+                        <a:t>SigLIP 2: Healthy</a:t>
+                      </a:r>
+                    </a:p>
+                  </a:txBody>
+                  <a:tcPr marL="91440" marR="91440" marT="45720" marB="45720" anchor="ctr">
+                    <a:solidFill>
+                      <a:srgbClr val="FFFFFF"/>
+                    </a:solidFill>
+                  </a:tcPr>
+                </a:tc>
+                <a:tc>
+                  <a:txBody>
+                    <a:bodyPr lIns="114300" tIns="114300" rIns="114300" bIns="114300"/>
+                    <a:lstStyle/>
+                    <a:p>
+                      <a:r>
+                        <a:rPr sz="1800" b="0">
+                          <a:solidFill>
+                            <a:srgbClr val="22362F"/>
+                          </a:solidFill>
+                          <a:latin typeface="Arial"/>
+                          <a:ea typeface="Arial"/>
+                          <a:cs typeface="Arial"/>
+                        </a:rPr>
+                        <a:t>100.00</a:t>
+                      </a:r>
+                    </a:p>
+                  </a:txBody>
+                  <a:tcPr marL="91440" marR="91440" marT="45720" marB="45720" anchor="ctr">
+                    <a:solidFill>
+                      <a:srgbClr val="FFFFFF"/>
+                    </a:solidFill>
+                  </a:tcPr>
+                </a:tc>
+                <a:tc>
+                  <a:txBody>
+                    <a:bodyPr lIns="114300" tIns="114300" rIns="114300" bIns="114300"/>
+                    <a:lstStyle/>
+                    <a:p>
+                      <a:r>
+                        <a:rPr sz="1800" b="0">
+                          <a:solidFill>
+                            <a:srgbClr val="22362F"/>
+                          </a:solidFill>
+                          <a:latin typeface="Arial"/>
+                          <a:ea typeface="Arial"/>
+                          <a:cs typeface="Arial"/>
+                        </a:rPr>
+                        <a:t>100.00</a:t>
+                      </a:r>
+                    </a:p>
+                  </a:txBody>
+                  <a:tcPr marL="91440" marR="91440" marT="45720" marB="45720" anchor="ctr">
+                    <a:solidFill>
+                      <a:srgbClr val="FFFFFF"/>
+                    </a:solidFill>
+                  </a:tcPr>
+                </a:tc>
+                <a:tc>
+                  <a:txBody>
+                    <a:bodyPr lIns="114300" tIns="114300" rIns="114300" bIns="114300"/>
+                    <a:lstStyle/>
+                    <a:p>
+                      <a:r>
+                        <a:rPr sz="1800" b="0">
+                          <a:solidFill>
+                            <a:srgbClr val="22362F"/>
+                          </a:solidFill>
+                          <a:latin typeface="Arial"/>
+                          <a:ea typeface="Arial"/>
+                          <a:cs typeface="Arial"/>
+                        </a:rPr>
+                        <a:t>100.00</a:t>
+                      </a:r>
+                    </a:p>
+                  </a:txBody>
+                  <a:tcPr marL="91440" marR="91440" marT="45720" marB="45720" anchor="ctr">
+                    <a:solidFill>
+                      <a:srgbClr val="FFFFFF"/>
+                    </a:solidFill>
+                  </a:tcPr>
+                </a:tc>
+              </a:tr>
+            </a:tbl>
+          </a:graphicData>
+        </a:graphic>
+      </p:graphicFrame>
+      <p:sp>
+        <p:nvSpPr>
+          <p:cNvPr id="5" name="">
+            <a:extLst xmlns:a="http://schemas.openxmlformats.org/drawingml/2006/main">
+              <a:ext uri="{FF2B5EF4-FFF2-40B4-BE49-F238E27FC236}">
+                <a16:creationId xmlns:a16="http://schemas.microsoft.com/office/drawing/2014/main" id="{A7935FF3-C3D2-4E6C-B248-606BBFC206A7}"/>
+              </a:ext>
+            </a:extLst>
+          </p:cNvPr>
+          <p:cNvSpPr>
+            <a:spLocks xmlns:a="http://schemas.openxmlformats.org/drawingml/2006/main" noGrp="1"/>
+          </p:cNvSpPr>
+          <p:nvPr/>
+        </p:nvSpPr>
+        <p:spPr>
+          <a:xfrm xmlns:a="http://schemas.openxmlformats.org/drawingml/2006/main">
+            <a:off x="609600" y="5410200"/>
+            <a:ext cx="10972800" cy="400050"/>
+          </a:xfrm>
+          <a:prstGeom xmlns:a="http://schemas.openxmlformats.org/drawingml/2006/main" prst="rect">
+            <a:avLst/>
+          </a:prstGeom>
+          <a:noFill xmlns:a="http://schemas.openxmlformats.org/drawingml/2006/main"/>
+          <a:ln xmlns:a="http://schemas.openxmlformats.org/drawingml/2006/main" w="0">
+            <a:noFill/>
+          </a:ln>
+        </p:spPr>
+        <p:txBody>
+          <a:bodyPr xmlns:a="http://schemas.openxmlformats.org/drawingml/2006/main" wrap="square" lIns="0" tIns="0" rIns="0" bIns="0" anchor="t">
+            <a:noAutofit/>
+          </a:bodyPr>
+          <a:lstStyle xmlns:a="http://schemas.openxmlformats.org/drawingml/2006/main">
+            <a:defPPr>
+              <a:defRPr sz="2100" b="1">
+                <a:solidFill>
+                  <a:srgbClr val="245844"/>
+                </a:solidFill>
+                <a:latin typeface="Arial"/>
+                <a:ea typeface="Arial"/>
+                <a:cs typeface="Arial"/>
+              </a:defRPr>
+            </a:defPPr>
+            <a:lvl1pPr>
+              <a:buNone/>
+              <a:defRPr sz="2100" b="1">
+                <a:solidFill>
+                  <a:srgbClr val="245844"/>
+                </a:solidFill>
+                <a:latin typeface="Arial"/>
+                <a:ea typeface="Arial"/>
+                <a:cs typeface="Arial"/>
+              </a:defRPr>
+            </a:lvl1pPr>
+            <a:lvl2pPr>
+              <a:buNone/>
+              <a:defRPr sz="2100" b="1">
+                <a:solidFill>
+                  <a:srgbClr val="245844"/>
+                </a:solidFill>
+                <a:latin typeface="Arial"/>
+                <a:ea typeface="Arial"/>
+                <a:cs typeface="Arial"/>
+              </a:defRPr>
+            </a:lvl2pPr>
+            <a:lvl3pPr>
+              <a:buNone/>
+              <a:defRPr sz="2100" b="1">
+                <a:solidFill>
+                  <a:srgbClr val="245844"/>
+                </a:solidFill>
+                <a:latin typeface="Arial"/>
+                <a:ea typeface="Arial"/>
+                <a:cs typeface="Arial"/>
+              </a:defRPr>
+            </a:lvl3pPr>
+            <a:lvl4pPr>
+              <a:buNone/>
+              <a:defRPr sz="2100" b="1">
+                <a:solidFill>
+                  <a:srgbClr val="245844"/>
+                </a:solidFill>
+                <a:latin typeface="Arial"/>
+                <a:ea typeface="Arial"/>
+                <a:cs typeface="Arial"/>
+              </a:defRPr>
+            </a:lvl4pPr>
+            <a:lvl5pPr>
+              <a:buNone/>
+              <a:defRPr sz="2100" b="1">
+                <a:solidFill>
+                  <a:srgbClr val="245844"/>
+                </a:solidFill>
+                <a:latin typeface="Arial"/>
+                <a:ea typeface="Arial"/>
+                <a:cs typeface="Arial"/>
+              </a:defRPr>
+            </a:lvl5pPr>
+            <a:lvl6pPr>
+              <a:buNone/>
+              <a:defRPr sz="2100" b="1">
+                <a:solidFill>
+                  <a:srgbClr val="245844"/>
+                </a:solidFill>
+                <a:latin typeface="Arial"/>
+                <a:ea typeface="Arial"/>
+                <a:cs typeface="Arial"/>
+              </a:defRPr>
+            </a:lvl6pPr>
+            <a:lvl7pPr>
+              <a:buNone/>
+              <a:defRPr sz="2100" b="1">
+                <a:solidFill>
+                  <a:srgbClr val="245844"/>
+                </a:solidFill>
+                <a:latin typeface="Arial"/>
+                <a:ea typeface="Arial"/>
+                <a:cs typeface="Arial"/>
+              </a:defRPr>
+            </a:lvl7pPr>
+            <a:lvl8pPr>
+              <a:buNone/>
+              <a:defRPr sz="2100" b="1">
+                <a:solidFill>
+                  <a:srgbClr val="245844"/>
+                </a:solidFill>
+                <a:latin typeface="Arial"/>
+                <a:ea typeface="Arial"/>
+                <a:cs typeface="Arial"/>
+              </a:defRPr>
+            </a:lvl8pPr>
+            <a:lvl9pPr>
+              <a:buNone/>
+              <a:defRPr sz="2100" b="1">
+                <a:solidFill>
+                  <a:srgbClr val="245844"/>
+                </a:solidFill>
+                <a:latin typeface="Arial"/>
+                <a:ea typeface="Arial"/>
+                <a:cs typeface="Arial"/>
+              </a:defRPr>
+            </a:lvl9pPr>
+          </a:lstStyle>
+          <a:p xmlns:a="http://schemas.openxmlformats.org/drawingml/2006/main">
+            <a:pPr>
+              <a:buNone/>
+              <a:defRPr sz="2100" b="1">
+                <a:solidFill>
+                  <a:srgbClr val="245844"/>
+                </a:solidFill>
+                <a:latin typeface="Arial"/>
+                <a:ea typeface="Arial"/>
+                <a:cs typeface="Arial"/>
+              </a:defRPr>
+            </a:pPr>
+            <a:r>
+              <a:rPr sz="2100" b="1">
+                <a:solidFill>
+                  <a:srgbClr val="245844"/>
+                </a:solidFill>
+                <a:latin typeface="Arial"/>
+                <a:ea typeface="Arial"/>
+                <a:cs typeface="Arial"/>
+              </a:rPr>
+              <a:t>Majority baseline: always predicts rust. Accuracy 33.59%, macro-F1 16.76%.</a:t>
+            </a:r>
+          </a:p>
+        </p:txBody>
+      </p:sp>
+      <p:sp>
+        <p:nvSpPr>
+          <p:cNvPr id="6" name="">
+            <a:extLst xmlns:a="http://schemas.openxmlformats.org/drawingml/2006/main">
+              <a:ext uri="{FF2B5EF4-FFF2-40B4-BE49-F238E27FC236}">
+                <a16:creationId xmlns:a16="http://schemas.microsoft.com/office/drawing/2014/main" id="{381A758C-7DD7-408A-8E69-F315335EA77E}"/>
+              </a:ext>
+            </a:extLst>
+          </p:cNvPr>
+          <p:cNvSpPr>
+            <a:spLocks xmlns:a="http://schemas.openxmlformats.org/drawingml/2006/main" noGrp="1"/>
+          </p:cNvSpPr>
+          <p:nvPr/>
+        </p:nvSpPr>
+        <p:spPr>
+          <a:xfrm xmlns:a="http://schemas.openxmlformats.org/drawingml/2006/main">
+            <a:off x="609600" y="6048375"/>
+            <a:ext cx="10477500" cy="552450"/>
+          </a:xfrm>
+          <a:prstGeom xmlns:a="http://schemas.openxmlformats.org/drawingml/2006/main" prst="rect">
+            <a:avLst/>
+          </a:prstGeom>
+          <a:noFill xmlns:a="http://schemas.openxmlformats.org/drawingml/2006/main"/>
+          <a:ln xmlns:a="http://schemas.openxmlformats.org/drawingml/2006/main" w="0">
+            <a:noFill/>
+          </a:ln>
+        </p:spPr>
+        <p:txBody>
+          <a:bodyPr xmlns:a="http://schemas.openxmlformats.org/drawingml/2006/main" wrap="square" lIns="0" tIns="0" rIns="0" bIns="0" anchor="t">
+            <a:noAutofit/>
+          </a:bodyPr>
+          <a:lstStyle xmlns:a="http://schemas.openxmlformats.org/drawingml/2006/main">
+            <a:defPPr>
+              <a:defRPr sz="1725" b="0">
+                <a:solidFill>
+                  <a:srgbClr val="5D6864"/>
+                </a:solidFill>
+                <a:latin typeface="Arial"/>
+                <a:ea typeface="Arial"/>
+                <a:cs typeface="Arial"/>
+              </a:defRPr>
+            </a:defPPr>
+            <a:lvl1pPr>
+              <a:buNone/>
+              <a:defRPr sz="1725" b="0">
+                <a:solidFill>
+                  <a:srgbClr val="5D6864"/>
+                </a:solidFill>
+                <a:latin typeface="Arial"/>
+                <a:ea typeface="Arial"/>
+                <a:cs typeface="Arial"/>
+              </a:defRPr>
+            </a:lvl1pPr>
+            <a:lvl2pPr>
+              <a:buNone/>
+              <a:defRPr sz="1725" b="0">
+                <a:solidFill>
+                  <a:srgbClr val="5D6864"/>
+                </a:solidFill>
+                <a:latin typeface="Arial"/>
+                <a:ea typeface="Arial"/>
+                <a:cs typeface="Arial"/>
+              </a:defRPr>
+            </a:lvl2pPr>
+            <a:lvl3pPr>
+              <a:buNone/>
+              <a:defRPr sz="1725" b="0">
+                <a:solidFill>
+                  <a:srgbClr val="5D6864"/>
+                </a:solidFill>
+                <a:latin typeface="Arial"/>
+                <a:ea typeface="Arial"/>
+                <a:cs typeface="Arial"/>
+              </a:defRPr>
+            </a:lvl3pPr>
+            <a:lvl4pPr>
+              <a:buNone/>
+              <a:defRPr sz="1725" b="0">
+                <a:solidFill>
+                  <a:srgbClr val="5D6864"/>
+                </a:solidFill>
+                <a:latin typeface="Arial"/>
+                <a:ea typeface="Arial"/>
+                <a:cs typeface="Arial"/>
+              </a:defRPr>
+            </a:lvl4pPr>
+            <a:lvl5pPr>
+              <a:buNone/>
+              <a:defRPr sz="1725" b="0">
+                <a:solidFill>
+                  <a:srgbClr val="5D6864"/>
+                </a:solidFill>
+                <a:latin typeface="Arial"/>
+                <a:ea typeface="Arial"/>
+                <a:cs typeface="Arial"/>
+              </a:defRPr>
+            </a:lvl5pPr>
+            <a:lvl6pPr>
+              <a:buNone/>
+              <a:defRPr sz="1725" b="0">
+                <a:solidFill>
+                  <a:srgbClr val="5D6864"/>
+                </a:solidFill>
+                <a:latin typeface="Arial"/>
+                <a:ea typeface="Arial"/>
+                <a:cs typeface="Arial"/>
+              </a:defRPr>
+            </a:lvl6pPr>
+            <a:lvl7pPr>
+              <a:buNone/>
+              <a:defRPr sz="1725" b="0">
+                <a:solidFill>
+                  <a:srgbClr val="5D6864"/>
+                </a:solidFill>
+                <a:latin typeface="Arial"/>
+                <a:ea typeface="Arial"/>
+                <a:cs typeface="Arial"/>
+              </a:defRPr>
+            </a:lvl7pPr>
+            <a:lvl8pPr>
+              <a:buNone/>
+              <a:defRPr sz="1725" b="0">
+                <a:solidFill>
+                  <a:srgbClr val="5D6864"/>
+                </a:solidFill>
+                <a:latin typeface="Arial"/>
+                <a:ea typeface="Arial"/>
+                <a:cs typeface="Arial"/>
+              </a:defRPr>
+            </a:lvl8pPr>
+            <a:lvl9pPr>
+              <a:buNone/>
+              <a:defRPr sz="1725" b="0">
+                <a:solidFill>
+                  <a:srgbClr val="5D6864"/>
+                </a:solidFill>
+                <a:latin typeface="Arial"/>
+                <a:ea typeface="Arial"/>
+                <a:cs typeface="Arial"/>
+              </a:defRPr>
+            </a:lvl9pPr>
+          </a:lstStyle>
+          <a:p xmlns:a="http://schemas.openxmlformats.org/drawingml/2006/main">
+            <a:pPr>
+              <a:buNone/>
+              <a:defRPr sz="1725" b="0">
+                <a:solidFill>
+                  <a:srgbClr val="5D6864"/>
+                </a:solidFill>
+                <a:latin typeface="Arial"/>
+                <a:ea typeface="Arial"/>
+                <a:cs typeface="Arial"/>
+              </a:defRPr>
+            </a:pPr>
+            <a:r>
+              <a:rPr sz="1725" b="0">
+                <a:solidFill>
+                  <a:srgbClr val="5D6864"/>
+                </a:solidFill>
+                <a:latin typeface="Arial"/>
+                <a:ea typeface="Arial"/>
+                <a:cs typeface="Arial"/>
+              </a:rPr>
+              <a:t>Baseline class chosen from training counts. Class support: 43 leaf spot, 43 rust, 42 healthy.</a:t>
+            </a:r>
+          </a:p>
+          <a:p xmlns:a="http://schemas.openxmlformats.org/drawingml/2006/main">
+            <a:pPr>
+              <a:buNone/>
+              <a:defRPr sz="1725" b="0">
+                <a:solidFill>
+                  <a:srgbClr val="5D6864"/>
+                </a:solidFill>
+                <a:latin typeface="Arial"/>
+                <a:ea typeface="Arial"/>
+                <a:cs typeface="Arial"/>
+              </a:defRPr>
+            </a:pPr>
+            <a:r>
+              <a:rPr sz="1725" b="0">
+                <a:solidFill>
+                  <a:srgbClr val="5D6864"/>
+                </a:solidFill>
+                <a:latin typeface="Arial"/>
+                <a:ea typeface="Arial"/>
+                <a:cs typeface="Arial"/>
+              </a:rPr>
+              <a:t>These are one-seed results, not the three-seed averages.</a:t>
+            </a:r>
+          </a:p>
+        </p:txBody>
+      </p:sp>
+    </p:spTree>
+    <p:extLst>
+      <p:ext uri="{BB962C8B-B14F-4D97-AF65-F5344CB8AC3E}">
+        <p14:creationId xmlns:p14="http://schemas.microsoft.com/office/powerpoint/2010/main" val="1892612243"/>
+      </p:ext>
+    </p:extLst>
+  </p:cSld>
+</p:sld>
+</file>
+
+<file path=ppt/slides/slide13.xml><?xml version="1.0" encoding="utf-8"?>
+<p:sld xmlns:p="http://schemas.openxmlformats.org/presentationml/2006/main">
+  <p:cSld>
+    <p:bg>
+      <p:bgPr>
+        <a:solidFill xmlns:a="http://schemas.openxmlformats.org/drawingml/2006/main">
+          <a:srgbClr val="FFFFFF"/>
+        </a:solidFill>
+      </p:bgPr>
+    </p:bg>
+    <p:spTree>
+      <p:nvGrpSpPr>
+        <p:cNvPr id="1" name=""/>
+        <p:cNvGrpSpPr/>
+        <p:nvPr/>
+      </p:nvGrpSpPr>
+      <p:grpSpPr>
+        <a:xfrm xmlns:a="http://schemas.openxmlformats.org/drawingml/2006/main"/>
+      </p:grpSpPr>
+      <p:sp>
+        <p:nvSpPr>
+          <p:cNvPr id="7" name="">
+            <a:extLst xmlns:a="http://schemas.openxmlformats.org/drawingml/2006/main">
+              <a:ext uri="{FF2B5EF4-FFF2-40B4-BE49-F238E27FC236}">
+                <a16:creationId xmlns:a16="http://schemas.microsoft.com/office/drawing/2014/main" id="{43A03CDD-BA11-4C70-834F-1EB1B97C6902}"/>
+              </a:ext>
+            </a:extLst>
+          </p:cNvPr>
+          <p:cNvSpPr>
+            <a:spLocks xmlns:a="http://schemas.openxmlformats.org/drawingml/2006/main" noGrp="1"/>
+          </p:cNvSpPr>
+          <p:nvPr/>
+        </p:nvSpPr>
+        <p:spPr>
+          <a:xfrm xmlns:a="http://schemas.openxmlformats.org/drawingml/2006/main">
+            <a:off x="609600" y="400050"/>
+            <a:ext cx="10810875" cy="1028700"/>
+          </a:xfrm>
+          <a:prstGeom xmlns:a="http://schemas.openxmlformats.org/drawingml/2006/main" prst="rect">
+            <a:avLst/>
+          </a:prstGeom>
+          <a:noFill xmlns:a="http://schemas.openxmlformats.org/drawingml/2006/main"/>
+          <a:ln xmlns:a="http://schemas.openxmlformats.org/drawingml/2006/main" w="0">
+            <a:noFill/>
+          </a:ln>
+        </p:spPr>
+        <p:txBody>
+          <a:bodyPr xmlns:a="http://schemas.openxmlformats.org/drawingml/2006/main" wrap="square" lIns="0" tIns="0" rIns="0" bIns="0" anchor="t">
+            <a:noAutofit/>
+          </a:bodyPr>
+          <a:lstStyle xmlns:a="http://schemas.openxmlformats.org/drawingml/2006/main">
+            <a:defPPr>
+              <a:defRPr sz="3300" b="1">
+                <a:solidFill>
+                  <a:srgbClr val="22362F"/>
+                </a:solidFill>
+                <a:latin typeface="Arial"/>
+                <a:ea typeface="Arial"/>
+                <a:cs typeface="Arial"/>
+              </a:defRPr>
+            </a:defPPr>
+            <a:lvl1pPr>
+              <a:buNone/>
+              <a:defRPr sz="3300" b="1">
+                <a:solidFill>
+                  <a:srgbClr val="22362F"/>
+                </a:solidFill>
+                <a:latin typeface="Arial"/>
+                <a:ea typeface="Arial"/>
+                <a:cs typeface="Arial"/>
+              </a:defRPr>
+            </a:lvl1pPr>
+            <a:lvl2pPr>
+              <a:buNone/>
+              <a:defRPr sz="3300" b="1">
+                <a:solidFill>
+                  <a:srgbClr val="22362F"/>
+                </a:solidFill>
+                <a:latin typeface="Arial"/>
+                <a:ea typeface="Arial"/>
+                <a:cs typeface="Arial"/>
+              </a:defRPr>
+            </a:lvl2pPr>
+            <a:lvl3pPr>
+              <a:buNone/>
+              <a:defRPr sz="3300" b="1">
+                <a:solidFill>
+                  <a:srgbClr val="22362F"/>
+                </a:solidFill>
+                <a:latin typeface="Arial"/>
+                <a:ea typeface="Arial"/>
+                <a:cs typeface="Arial"/>
+              </a:defRPr>
+            </a:lvl3pPr>
+            <a:lvl4pPr>
+              <a:buNone/>
+              <a:defRPr sz="3300" b="1">
+                <a:solidFill>
+                  <a:srgbClr val="22362F"/>
+                </a:solidFill>
+                <a:latin typeface="Arial"/>
+                <a:ea typeface="Arial"/>
+                <a:cs typeface="Arial"/>
+              </a:defRPr>
+            </a:lvl4pPr>
+            <a:lvl5pPr>
+              <a:buNone/>
+              <a:defRPr sz="3300" b="1">
+                <a:solidFill>
+                  <a:srgbClr val="22362F"/>
+                </a:solidFill>
+                <a:latin typeface="Arial"/>
+                <a:ea typeface="Arial"/>
+                <a:cs typeface="Arial"/>
+              </a:defRPr>
+            </a:lvl5pPr>
+            <a:lvl6pPr>
+              <a:buNone/>
+              <a:defRPr sz="3300" b="1">
+                <a:solidFill>
+                  <a:srgbClr val="22362F"/>
+                </a:solidFill>
+                <a:latin typeface="Arial"/>
+                <a:ea typeface="Arial"/>
+                <a:cs typeface="Arial"/>
+              </a:defRPr>
+            </a:lvl6pPr>
+            <a:lvl7pPr>
+              <a:buNone/>
+              <a:defRPr sz="3300" b="1">
+                <a:solidFill>
+                  <a:srgbClr val="22362F"/>
+                </a:solidFill>
+                <a:latin typeface="Arial"/>
+                <a:ea typeface="Arial"/>
+                <a:cs typeface="Arial"/>
+              </a:defRPr>
+            </a:lvl7pPr>
+            <a:lvl8pPr>
+              <a:buNone/>
+              <a:defRPr sz="3300" b="1">
+                <a:solidFill>
+                  <a:srgbClr val="22362F"/>
+                </a:solidFill>
+                <a:latin typeface="Arial"/>
+                <a:ea typeface="Arial"/>
+                <a:cs typeface="Arial"/>
+              </a:defRPr>
+            </a:lvl8pPr>
+            <a:lvl9pPr>
+              <a:buNone/>
+              <a:defRPr sz="3300" b="1">
+                <a:solidFill>
+                  <a:srgbClr val="22362F"/>
+                </a:solidFill>
+                <a:latin typeface="Arial"/>
+                <a:ea typeface="Arial"/>
+                <a:cs typeface="Arial"/>
+              </a:defRPr>
+            </a:lvl9pPr>
+          </a:lstStyle>
+          <a:p xmlns:a="http://schemas.openxmlformats.org/drawingml/2006/main">
+            <a:pPr>
+              <a:buNone/>
+              <a:defRPr sz="3300" b="1">
+                <a:solidFill>
+                  <a:srgbClr val="22362F"/>
+                </a:solidFill>
+                <a:latin typeface="Arial"/>
+                <a:ea typeface="Arial"/>
+                <a:cs typeface="Arial"/>
+              </a:defRPr>
+            </a:pPr>
+            <a:r>
+              <a:rPr sz="3300" b="1">
+                <a:solidFill>
+                  <a:srgbClr val="22362F"/>
+                </a:solidFill>
+                <a:latin typeface="Arial"/>
+                <a:ea typeface="Arial"/>
+                <a:cs typeface="Arial"/>
+              </a:rPr>
+              <a:t>A small check under blur and darkening</a:t>
+            </a:r>
+          </a:p>
+        </p:txBody>
+      </p:sp>
+      <p:sp>
+        <p:nvSpPr>
+          <p:cNvPr id="2" name="">
+            <a:extLst xmlns:a="http://schemas.openxmlformats.org/drawingml/2006/main">
+              <a:ext uri="{FF2B5EF4-FFF2-40B4-BE49-F238E27FC236}">
+                <a16:creationId xmlns:a16="http://schemas.microsoft.com/office/drawing/2014/main" id="{9D2E01D1-19A4-409D-AA17-9C8DD4AEB049}"/>
+              </a:ext>
+            </a:extLst>
+          </p:cNvPr>
+          <p:cNvSpPr>
+            <a:spLocks xmlns:a="http://schemas.openxmlformats.org/drawingml/2006/main" noGrp="1"/>
+          </p:cNvSpPr>
+          <p:nvPr/>
+        </p:nvSpPr>
+        <p:spPr>
+          <a:xfrm xmlns:a="http://schemas.openxmlformats.org/drawingml/2006/main">
+            <a:off x="11144250" y="6381750"/>
+            <a:ext cx="438150" cy="228600"/>
+          </a:xfrm>
+          <a:prstGeom xmlns:a="http://schemas.openxmlformats.org/drawingml/2006/main" prst="rect">
+            <a:avLst/>
+          </a:prstGeom>
+          <a:noFill xmlns:a="http://schemas.openxmlformats.org/drawingml/2006/main"/>
+          <a:ln xmlns:a="http://schemas.openxmlformats.org/drawingml/2006/main" w="0">
+            <a:noFill/>
+          </a:ln>
+        </p:spPr>
+        <p:txBody>
+          <a:bodyPr xmlns:a="http://schemas.openxmlformats.org/drawingml/2006/main" wrap="square" lIns="0" tIns="0" rIns="0" bIns="0" anchor="t">
+            <a:noAutofit/>
+          </a:bodyPr>
+          <a:lstStyle xmlns:a="http://schemas.openxmlformats.org/drawingml/2006/main">
+            <a:defPPr>
+              <a:defRPr sz="1350" b="0">
+                <a:solidFill>
+                  <a:srgbClr val="5D6864"/>
+                </a:solidFill>
+                <a:latin typeface="Arial"/>
+                <a:ea typeface="Arial"/>
+                <a:cs typeface="Arial"/>
+              </a:defRPr>
+            </a:defPPr>
+            <a:lvl1pPr>
+              <a:buNone/>
+              <a:defRPr sz="1350" b="0">
+                <a:solidFill>
+                  <a:srgbClr val="5D6864"/>
+                </a:solidFill>
+                <a:latin typeface="Arial"/>
+                <a:ea typeface="Arial"/>
+                <a:cs typeface="Arial"/>
+              </a:defRPr>
+            </a:lvl1pPr>
+            <a:lvl2pPr>
+              <a:buNone/>
+              <a:defRPr sz="1350" b="0">
+                <a:solidFill>
+                  <a:srgbClr val="5D6864"/>
+                </a:solidFill>
+                <a:latin typeface="Arial"/>
+                <a:ea typeface="Arial"/>
+                <a:cs typeface="Arial"/>
+              </a:defRPr>
+            </a:lvl2pPr>
+            <a:lvl3pPr>
+              <a:buNone/>
+              <a:defRPr sz="1350" b="0">
+                <a:solidFill>
+                  <a:srgbClr val="5D6864"/>
+                </a:solidFill>
+                <a:latin typeface="Arial"/>
+                <a:ea typeface="Arial"/>
+                <a:cs typeface="Arial"/>
+              </a:defRPr>
+            </a:lvl3pPr>
+            <a:lvl4pPr>
+              <a:buNone/>
+              <a:defRPr sz="1350" b="0">
+                <a:solidFill>
+                  <a:srgbClr val="5D6864"/>
+                </a:solidFill>
+                <a:latin typeface="Arial"/>
+                <a:ea typeface="Arial"/>
+                <a:cs typeface="Arial"/>
+              </a:defRPr>
+            </a:lvl4pPr>
+            <a:lvl5pPr>
+              <a:buNone/>
+              <a:defRPr sz="1350" b="0">
+                <a:solidFill>
+                  <a:srgbClr val="5D6864"/>
+                </a:solidFill>
+                <a:latin typeface="Arial"/>
+                <a:ea typeface="Arial"/>
+                <a:cs typeface="Arial"/>
+              </a:defRPr>
+            </a:lvl5pPr>
+            <a:lvl6pPr>
+              <a:buNone/>
+              <a:defRPr sz="1350" b="0">
+                <a:solidFill>
+                  <a:srgbClr val="5D6864"/>
+                </a:solidFill>
+                <a:latin typeface="Arial"/>
+                <a:ea typeface="Arial"/>
+                <a:cs typeface="Arial"/>
+              </a:defRPr>
+            </a:lvl6pPr>
+            <a:lvl7pPr>
+              <a:buNone/>
+              <a:defRPr sz="1350" b="0">
+                <a:solidFill>
+                  <a:srgbClr val="5D6864"/>
+                </a:solidFill>
+                <a:latin typeface="Arial"/>
+                <a:ea typeface="Arial"/>
+                <a:cs typeface="Arial"/>
+              </a:defRPr>
+            </a:lvl7pPr>
+            <a:lvl8pPr>
+              <a:buNone/>
+              <a:defRPr sz="1350" b="0">
+                <a:solidFill>
+                  <a:srgbClr val="5D6864"/>
+                </a:solidFill>
+                <a:latin typeface="Arial"/>
+                <a:ea typeface="Arial"/>
+                <a:cs typeface="Arial"/>
+              </a:defRPr>
+            </a:lvl8pPr>
+            <a:lvl9pPr>
+              <a:buNone/>
+              <a:defRPr sz="1350" b="0">
+                <a:solidFill>
+                  <a:srgbClr val="5D6864"/>
+                </a:solidFill>
+                <a:latin typeface="Arial"/>
+                <a:ea typeface="Arial"/>
+                <a:cs typeface="Arial"/>
+              </a:defRPr>
+            </a:lvl9pPr>
+          </a:lstStyle>
+          <a:p xmlns:a="http://schemas.openxmlformats.org/drawingml/2006/main">
+            <a:pPr>
+              <a:buNone/>
+              <a:defRPr sz="1350" b="0">
+                <a:solidFill>
+                  <a:srgbClr val="5D6864"/>
+                </a:solidFill>
+                <a:latin typeface="Arial"/>
+                <a:ea typeface="Arial"/>
+                <a:cs typeface="Arial"/>
+              </a:defRPr>
+            </a:pPr>
+            <a:r>
+              <a:rPr sz="1350" b="0">
+                <a:solidFill>
+                  <a:srgbClr val="5D6864"/>
+                </a:solidFill>
+                <a:latin typeface="Arial"/>
+                <a:ea typeface="Arial"/>
+                <a:cs typeface="Arial"/>
+              </a:rPr>
+              <a:t>13</a:t>
+            </a:r>
+          </a:p>
+        </p:txBody>
+      </p:sp>
+      <p:sp>
+        <p:nvSpPr>
+          <p:cNvPr id="3" name="">
+            <a:extLst xmlns:a="http://schemas.openxmlformats.org/drawingml/2006/main">
+              <a:ext uri="{FF2B5EF4-FFF2-40B4-BE49-F238E27FC236}">
+                <a16:creationId xmlns:a16="http://schemas.microsoft.com/office/drawing/2014/main" id="{87E2D9A9-4ED1-46EE-9F09-E321600015F3}"/>
+              </a:ext>
+            </a:extLst>
+          </p:cNvPr>
+          <p:cNvSpPr>
+            <a:spLocks xmlns:a="http://schemas.openxmlformats.org/drawingml/2006/main" noGrp="1"/>
+          </p:cNvSpPr>
+          <p:nvPr/>
+        </p:nvSpPr>
+        <p:spPr>
+          <a:xfrm xmlns:a="http://schemas.openxmlformats.org/drawingml/2006/main">
+            <a:off x="609600" y="1066800"/>
+            <a:ext cx="10972800" cy="323850"/>
+          </a:xfrm>
+          <a:prstGeom xmlns:a="http://schemas.openxmlformats.org/drawingml/2006/main" prst="rect">
+            <a:avLst/>
+          </a:prstGeom>
+          <a:noFill xmlns:a="http://schemas.openxmlformats.org/drawingml/2006/main"/>
+          <a:ln xmlns:a="http://schemas.openxmlformats.org/drawingml/2006/main" w="0">
+            <a:noFill/>
+          </a:ln>
+        </p:spPr>
+        <p:txBody>
+          <a:bodyPr xmlns:a="http://schemas.openxmlformats.org/drawingml/2006/main" wrap="square" lIns="0" tIns="0" rIns="0" bIns="0" anchor="t">
+            <a:noAutofit/>
+          </a:bodyPr>
+          <a:lstStyle xmlns:a="http://schemas.openxmlformats.org/drawingml/2006/main">
+            <a:defPPr>
+              <a:defRPr sz="1875" b="0">
+                <a:solidFill>
+                  <a:srgbClr val="5D6864"/>
+                </a:solidFill>
+                <a:latin typeface="Arial"/>
+                <a:ea typeface="Arial"/>
+                <a:cs typeface="Arial"/>
+              </a:defRPr>
+            </a:defPPr>
+            <a:lvl1pPr>
+              <a:buNone/>
+              <a:defRPr sz="1875" b="0">
+                <a:solidFill>
+                  <a:srgbClr val="5D6864"/>
+                </a:solidFill>
+                <a:latin typeface="Arial"/>
+                <a:ea typeface="Arial"/>
+                <a:cs typeface="Arial"/>
+              </a:defRPr>
+            </a:lvl1pPr>
+            <a:lvl2pPr>
+              <a:buNone/>
+              <a:defRPr sz="1875" b="0">
+                <a:solidFill>
+                  <a:srgbClr val="5D6864"/>
+                </a:solidFill>
+                <a:latin typeface="Arial"/>
+                <a:ea typeface="Arial"/>
+                <a:cs typeface="Arial"/>
+              </a:defRPr>
+            </a:lvl2pPr>
+            <a:lvl3pPr>
+              <a:buNone/>
+              <a:defRPr sz="1875" b="0">
+                <a:solidFill>
+                  <a:srgbClr val="5D6864"/>
+                </a:solidFill>
+                <a:latin typeface="Arial"/>
+                <a:ea typeface="Arial"/>
+                <a:cs typeface="Arial"/>
+              </a:defRPr>
+            </a:lvl3pPr>
+            <a:lvl4pPr>
+              <a:buNone/>
+              <a:defRPr sz="1875" b="0">
+                <a:solidFill>
+                  <a:srgbClr val="5D6864"/>
+                </a:solidFill>
+                <a:latin typeface="Arial"/>
+                <a:ea typeface="Arial"/>
+                <a:cs typeface="Arial"/>
+              </a:defRPr>
+            </a:lvl4pPr>
+            <a:lvl5pPr>
+              <a:buNone/>
+              <a:defRPr sz="1875" b="0">
+                <a:solidFill>
+                  <a:srgbClr val="5D6864"/>
+                </a:solidFill>
+                <a:latin typeface="Arial"/>
+                <a:ea typeface="Arial"/>
+                <a:cs typeface="Arial"/>
+              </a:defRPr>
+            </a:lvl5pPr>
+            <a:lvl6pPr>
+              <a:buNone/>
+              <a:defRPr sz="1875" b="0">
+                <a:solidFill>
+                  <a:srgbClr val="5D6864"/>
+                </a:solidFill>
+                <a:latin typeface="Arial"/>
+                <a:ea typeface="Arial"/>
+                <a:cs typeface="Arial"/>
+              </a:defRPr>
+            </a:lvl6pPr>
+            <a:lvl7pPr>
+              <a:buNone/>
+              <a:defRPr sz="1875" b="0">
+                <a:solidFill>
+                  <a:srgbClr val="5D6864"/>
+                </a:solidFill>
+                <a:latin typeface="Arial"/>
+                <a:ea typeface="Arial"/>
+                <a:cs typeface="Arial"/>
+              </a:defRPr>
+            </a:lvl7pPr>
+            <a:lvl8pPr>
+              <a:buNone/>
+              <a:defRPr sz="1875" b="0">
+                <a:solidFill>
+                  <a:srgbClr val="5D6864"/>
+                </a:solidFill>
+                <a:latin typeface="Arial"/>
+                <a:ea typeface="Arial"/>
+                <a:cs typeface="Arial"/>
+              </a:defRPr>
+            </a:lvl8pPr>
+            <a:lvl9pPr>
+              <a:buNone/>
+              <a:defRPr sz="1875" b="0">
+                <a:solidFill>
+                  <a:srgbClr val="5D6864"/>
+                </a:solidFill>
+                <a:latin typeface="Arial"/>
+                <a:ea typeface="Arial"/>
+                <a:cs typeface="Arial"/>
+              </a:defRPr>
+            </a:lvl9pPr>
+          </a:lstStyle>
+          <a:p xmlns:a="http://schemas.openxmlformats.org/drawingml/2006/main">
+            <a:pPr>
+              <a:buNone/>
+              <a:defRPr sz="1875" b="0">
+                <a:solidFill>
+                  <a:srgbClr val="5D6864"/>
+                </a:solidFill>
+                <a:latin typeface="Arial"/>
+                <a:ea typeface="Arial"/>
+                <a:cs typeface="Arial"/>
+              </a:defRPr>
+            </a:pPr>
+            <a:r>
+              <a:rPr sz="1875" b="0">
+                <a:solidFill>
+                  <a:srgbClr val="5D6864"/>
+                </a:solidFill>
+                <a:latin typeface="Arial"/>
+                <a:ea typeface="Arial"/>
+                <a:cs typeface="Arial"/>
+              </a:rPr>
+              <a:t>Partial fine-tuning, reference seed 17, same 128 test images</a:t>
+            </a:r>
+          </a:p>
+        </p:txBody>
+      </p:sp>
+      <p:graphicFrame>
+        <p:nvGraphicFramePr>
+          <p:cNvPr id="4" name="">
+            <a:extLst xmlns:a="http://schemas.openxmlformats.org/drawingml/2006/main">
+              <a:ext uri="{FF2B5EF4-FFF2-40B4-BE49-F238E27FC236}">
+                <a16:creationId xmlns:a16="http://schemas.microsoft.com/office/drawing/2014/main" id="{B21B88CE-4489-4BC2-8774-542AE894C964}"/>
+              </a:ext>
+            </a:extLst>
+          </p:cNvPr>
+          <p:cNvGraphicFramePr/>
+          <p:nvPr/>
+        </p:nvGraphicFramePr>
+        <p:xfrm>
+          <a:off xmlns:a="http://schemas.openxmlformats.org/drawingml/2006/main" x="609600" y="1714500"/>
+          <a:ext xmlns:a="http://schemas.openxmlformats.org/drawingml/2006/main" cx="10972800" cy="2895600"/>
+        </p:xfrm>
+        <a:graphic xmlns:a="http://schemas.openxmlformats.org/drawingml/2006/main">
+          <a:graphicData uri="http://schemas.openxmlformats.org/drawingml/2006/table">
+            <a:tbl>
+              <a:tblPr/>
+              <a:tblGrid>
+                <a:gridCol w="4229100"/>
+                <a:gridCol w="3371850"/>
+                <a:gridCol w="3371850"/>
+              </a:tblGrid>
+              <a:tr h="723900">
+                <a:tc>
+                  <a:txBody>
+                    <a:bodyPr lIns="114300" tIns="114300" rIns="114300" bIns="114300"/>
+                    <a:lstStyle/>
+                    <a:p>
+                      <a:r>
+                        <a:rPr sz="1875" b="1">
+                          <a:solidFill>
+                            <a:srgbClr val="22362F"/>
+                          </a:solidFill>
+                          <a:latin typeface="Arial"/>
+                          <a:ea typeface="Arial"/>
+                          <a:cs typeface="Arial"/>
+                        </a:rPr>
+                        <a:t>Test condition</a:t>
+                      </a:r>
+                    </a:p>
+                  </a:txBody>
+                  <a:tcPr marL="91440" marR="91440" marT="45720" marB="45720" anchor="ctr">
+                    <a:solidFill>
+                      <a:srgbClr val="E8EEEB"/>
+                    </a:solidFill>
+                  </a:tcPr>
+                </a:tc>
+                <a:tc>
+                  <a:txBody>
+                    <a:bodyPr lIns="114300" tIns="114300" rIns="114300" bIns="114300"/>
+                    <a:lstStyle/>
+                    <a:p>
+                      <a:r>
+                        <a:rPr sz="1875" b="1">
+                          <a:solidFill>
+                            <a:srgbClr val="22362F"/>
+                          </a:solidFill>
+                          <a:latin typeface="Arial"/>
+                          <a:ea typeface="Arial"/>
+                          <a:cs typeface="Arial"/>
+                        </a:rPr>
+                        <a:t>DINOv2 macro-F1 (%)</a:t>
+                      </a:r>
+                    </a:p>
+                  </a:txBody>
+                  <a:tcPr marL="91440" marR="91440" marT="45720" marB="45720" anchor="ctr">
+                    <a:solidFill>
+                      <a:srgbClr val="E8EEEB"/>
+                    </a:solidFill>
+                  </a:tcPr>
+                </a:tc>
+                <a:tc>
+                  <a:txBody>
+                    <a:bodyPr lIns="114300" tIns="114300" rIns="114300" bIns="114300"/>
+                    <a:lstStyle/>
+                    <a:p>
+                      <a:r>
+                        <a:rPr sz="1875" b="1">
+                          <a:solidFill>
+                            <a:srgbClr val="22362F"/>
+                          </a:solidFill>
+                          <a:latin typeface="Arial"/>
+                          <a:ea typeface="Arial"/>
+                          <a:cs typeface="Arial"/>
+                        </a:rPr>
+                        <a:t>SigLIP 2 macro-F1 (%)</a:t>
+                      </a:r>
+                    </a:p>
+                  </a:txBody>
+                  <a:tcPr marL="91440" marR="91440" marT="45720" marB="45720" anchor="ctr">
+                    <a:solidFill>
+                      <a:srgbClr val="E8EEEB"/>
+                    </a:solidFill>
+                  </a:tcPr>
+                </a:tc>
+              </a:tr>
+              <a:tr h="723900">
+                <a:tc>
+                  <a:txBody>
+                    <a:bodyPr lIns="114300" tIns="114300" rIns="114300" bIns="114300"/>
+                    <a:lstStyle/>
+                    <a:p>
+                      <a:r>
+                        <a:rPr sz="1875" b="0">
+                          <a:solidFill>
+                            <a:srgbClr val="22362F"/>
+                          </a:solidFill>
+                          <a:latin typeface="Arial"/>
+                          <a:ea typeface="Arial"/>
+                          <a:cs typeface="Arial"/>
+                        </a:rPr>
+                        <a:t>Clean images</a:t>
+                      </a:r>
+                    </a:p>
+                  </a:txBody>
+                  <a:tcPr marL="91440" marR="91440" marT="45720" marB="45720" anchor="ctr">
+                    <a:solidFill>
+                      <a:srgbClr val="FFFFFF"/>
+                    </a:solidFill>
+                  </a:tcPr>
+                </a:tc>
+                <a:tc>
+                  <a:txBody>
+                    <a:bodyPr lIns="114300" tIns="114300" rIns="114300" bIns="114300"/>
+                    <a:lstStyle/>
+                    <a:p>
+                      <a:r>
+                        <a:rPr sz="1875" b="0">
+                          <a:solidFill>
+                            <a:srgbClr val="22362F"/>
+                          </a:solidFill>
+                          <a:latin typeface="Arial"/>
+                          <a:ea typeface="Arial"/>
+                          <a:cs typeface="Arial"/>
+                        </a:rPr>
+                        <a:t>98.45</a:t>
+                      </a:r>
+                    </a:p>
+                  </a:txBody>
+                  <a:tcPr marL="91440" marR="91440" marT="45720" marB="45720" anchor="ctr">
+                    <a:solidFill>
+                      <a:srgbClr val="FFFFFF"/>
+                    </a:solidFill>
+                  </a:tcPr>
+                </a:tc>
+                <a:tc>
+                  <a:txBody>
+                    <a:bodyPr lIns="114300" tIns="114300" rIns="114300" bIns="114300"/>
+                    <a:lstStyle/>
+                    <a:p>
+                      <a:r>
+                        <a:rPr sz="1875" b="0">
+                          <a:solidFill>
+                            <a:srgbClr val="22362F"/>
+                          </a:solidFill>
+                          <a:latin typeface="Arial"/>
+                          <a:ea typeface="Arial"/>
+                          <a:cs typeface="Arial"/>
+                        </a:rPr>
+                        <a:t>97.67</a:t>
+                      </a:r>
+                    </a:p>
+                  </a:txBody>
+                  <a:tcPr marL="91440" marR="91440" marT="45720" marB="45720" anchor="ctr">
+                    <a:solidFill>
+                      <a:srgbClr val="FFFFFF"/>
+                    </a:solidFill>
+                  </a:tcPr>
+                </a:tc>
+              </a:tr>
+              <a:tr h="723900">
+                <a:tc>
+                  <a:txBody>
+                    <a:bodyPr lIns="114300" tIns="114300" rIns="114300" bIns="114300"/>
+                    <a:lstStyle/>
+                    <a:p>
+                      <a:r>
+                        <a:rPr sz="1875" b="0">
+                          <a:solidFill>
+                            <a:srgbClr val="22362F"/>
+                          </a:solidFill>
+                          <a:latin typeface="Arial"/>
+                          <a:ea typeface="Arial"/>
+                          <a:cs typeface="Arial"/>
+                        </a:rPr>
+                        <a:t>Gaussian blur, radius 1</a:t>
+                      </a:r>
+                    </a:p>
+                  </a:txBody>
+                  <a:tcPr marL="91440" marR="91440" marT="45720" marB="45720" anchor="ctr">
+                    <a:solidFill>
+                      <a:srgbClr val="FFFFFF"/>
+                    </a:solidFill>
+                  </a:tcPr>
+                </a:tc>
+                <a:tc>
+                  <a:txBody>
+                    <a:bodyPr lIns="114300" tIns="114300" rIns="114300" bIns="114300"/>
+                    <a:lstStyle/>
+                    <a:p>
+                      <a:r>
+                        <a:rPr sz="1875" b="0">
+                          <a:solidFill>
+                            <a:srgbClr val="22362F"/>
+                          </a:solidFill>
+                          <a:latin typeface="Arial"/>
+                          <a:ea typeface="Arial"/>
+                          <a:cs typeface="Arial"/>
+                        </a:rPr>
+                        <a:t>97.67</a:t>
+                      </a:r>
+                    </a:p>
+                  </a:txBody>
+                  <a:tcPr marL="91440" marR="91440" marT="45720" marB="45720" anchor="ctr">
+                    <a:solidFill>
+                      <a:srgbClr val="FFFFFF"/>
+                    </a:solidFill>
+                  </a:tcPr>
+                </a:tc>
+                <a:tc>
+                  <a:txBody>
+                    <a:bodyPr lIns="114300" tIns="114300" rIns="114300" bIns="114300"/>
+                    <a:lstStyle/>
+                    <a:p>
+                      <a:r>
+                        <a:rPr sz="1875" b="0">
+                          <a:solidFill>
+                            <a:srgbClr val="22362F"/>
+                          </a:solidFill>
+                          <a:latin typeface="Arial"/>
+                          <a:ea typeface="Arial"/>
+                          <a:cs typeface="Arial"/>
+                        </a:rPr>
+                        <a:t>96.07</a:t>
+                      </a:r>
+                    </a:p>
+                  </a:txBody>
+                  <a:tcPr marL="91440" marR="91440" marT="45720" marB="45720" anchor="ctr">
+                    <a:solidFill>
+                      <a:srgbClr val="FFFFFF"/>
+                    </a:solidFill>
+                  </a:tcPr>
+                </a:tc>
+              </a:tr>
+              <a:tr h="723900">
+                <a:tc>
+                  <a:txBody>
+                    <a:bodyPr lIns="114300" tIns="114300" rIns="114300" bIns="114300"/>
+                    <a:lstStyle/>
+                    <a:p>
+                      <a:r>
+                        <a:rPr sz="1875" b="0">
+                          <a:solidFill>
+                            <a:srgbClr val="22362F"/>
+                          </a:solidFill>
+                          <a:latin typeface="Arial"/>
+                          <a:ea typeface="Arial"/>
+                          <a:cs typeface="Arial"/>
+                        </a:rPr>
+                        <a:t>Brightness × 0.7</a:t>
+                      </a:r>
+                    </a:p>
+                  </a:txBody>
+                  <a:tcPr marL="91440" marR="91440" marT="45720" marB="45720" anchor="ctr">
+                    <a:solidFill>
+                      <a:srgbClr val="FFFFFF"/>
+                    </a:solidFill>
+                  </a:tcPr>
+                </a:tc>
+                <a:tc>
+                  <a:txBody>
+                    <a:bodyPr lIns="114300" tIns="114300" rIns="114300" bIns="114300"/>
+                    <a:lstStyle/>
+                    <a:p>
+                      <a:r>
+                        <a:rPr sz="1875" b="0">
+                          <a:solidFill>
+                            <a:srgbClr val="22362F"/>
+                          </a:solidFill>
+                          <a:latin typeface="Arial"/>
+                          <a:ea typeface="Arial"/>
+                          <a:cs typeface="Arial"/>
+                        </a:rPr>
+                        <a:t>98.45</a:t>
+                      </a:r>
+                    </a:p>
+                  </a:txBody>
+                  <a:tcPr marL="91440" marR="91440" marT="45720" marB="45720" anchor="ctr">
+                    <a:solidFill>
+                      <a:srgbClr val="FFFFFF"/>
+                    </a:solidFill>
+                  </a:tcPr>
+                </a:tc>
+                <a:tc>
+                  <a:txBody>
+                    <a:bodyPr lIns="114300" tIns="114300" rIns="114300" bIns="114300"/>
+                    <a:lstStyle/>
+                    <a:p>
+                      <a:r>
+                        <a:rPr sz="1875" b="0">
+                          <a:solidFill>
+                            <a:srgbClr val="22362F"/>
+                          </a:solidFill>
+                          <a:latin typeface="Arial"/>
+                          <a:ea typeface="Arial"/>
+                          <a:cs typeface="Arial"/>
+                        </a:rPr>
+                        <a:t>97.67</a:t>
+                      </a:r>
+                    </a:p>
+                  </a:txBody>
+                  <a:tcPr marL="91440" marR="91440" marT="45720" marB="45720" anchor="ctr">
+                    <a:solidFill>
+                      <a:srgbClr val="FFFFFF"/>
+                    </a:solidFill>
+                  </a:tcPr>
+                </a:tc>
+              </a:tr>
+            </a:tbl>
+          </a:graphicData>
+        </a:graphic>
+      </p:graphicFrame>
+      <p:sp>
+        <p:nvSpPr>
+          <p:cNvPr id="5" name="">
+            <a:extLst xmlns:a="http://schemas.openxmlformats.org/drawingml/2006/main">
+              <a:ext uri="{FF2B5EF4-FFF2-40B4-BE49-F238E27FC236}">
+                <a16:creationId xmlns:a16="http://schemas.microsoft.com/office/drawing/2014/main" id="{D2A3B4DB-33DB-45D6-BDB8-0DDA2183EB1A}"/>
+              </a:ext>
+            </a:extLst>
+          </p:cNvPr>
+          <p:cNvSpPr>
+            <a:spLocks xmlns:a="http://schemas.openxmlformats.org/drawingml/2006/main" noGrp="1"/>
+          </p:cNvSpPr>
+          <p:nvPr/>
+        </p:nvSpPr>
+        <p:spPr>
+          <a:xfrm xmlns:a="http://schemas.openxmlformats.org/drawingml/2006/main">
+            <a:off x="609600" y="5048250"/>
+            <a:ext cx="10972800" cy="419100"/>
+          </a:xfrm>
+          <a:prstGeom xmlns:a="http://schemas.openxmlformats.org/drawingml/2006/main" prst="rect">
+            <a:avLst/>
+          </a:prstGeom>
+          <a:noFill xmlns:a="http://schemas.openxmlformats.org/drawingml/2006/main"/>
+          <a:ln xmlns:a="http://schemas.openxmlformats.org/drawingml/2006/main" w="0">
+            <a:noFill/>
+          </a:ln>
+        </p:spPr>
+        <p:txBody>
+          <a:bodyPr xmlns:a="http://schemas.openxmlformats.org/drawingml/2006/main" wrap="square" lIns="0" tIns="0" rIns="0" bIns="0" anchor="t">
+            <a:noAutofit/>
+          </a:bodyPr>
+          <a:lstStyle xmlns:a="http://schemas.openxmlformats.org/drawingml/2006/main">
+            <a:defPPr>
+              <a:defRPr sz="2325" b="1">
+                <a:solidFill>
+                  <a:srgbClr val="245844"/>
+                </a:solidFill>
+                <a:latin typeface="Arial"/>
+                <a:ea typeface="Arial"/>
+                <a:cs typeface="Arial"/>
+              </a:defRPr>
+            </a:defPPr>
+            <a:lvl1pPr>
+              <a:buNone/>
+              <a:defRPr sz="2325" b="1">
+                <a:solidFill>
+                  <a:srgbClr val="245844"/>
+                </a:solidFill>
+                <a:latin typeface="Arial"/>
+                <a:ea typeface="Arial"/>
+                <a:cs typeface="Arial"/>
+              </a:defRPr>
+            </a:lvl1pPr>
+            <a:lvl2pPr>
+              <a:buNone/>
+              <a:defRPr sz="2325" b="1">
+                <a:solidFill>
+                  <a:srgbClr val="245844"/>
+                </a:solidFill>
+                <a:latin typeface="Arial"/>
+                <a:ea typeface="Arial"/>
+                <a:cs typeface="Arial"/>
+              </a:defRPr>
+            </a:lvl2pPr>
+            <a:lvl3pPr>
+              <a:buNone/>
+              <a:defRPr sz="2325" b="1">
+                <a:solidFill>
+                  <a:srgbClr val="245844"/>
+                </a:solidFill>
+                <a:latin typeface="Arial"/>
+                <a:ea typeface="Arial"/>
+                <a:cs typeface="Arial"/>
+              </a:defRPr>
+            </a:lvl3pPr>
+            <a:lvl4pPr>
+              <a:buNone/>
+              <a:defRPr sz="2325" b="1">
+                <a:solidFill>
+                  <a:srgbClr val="245844"/>
+                </a:solidFill>
+                <a:latin typeface="Arial"/>
+                <a:ea typeface="Arial"/>
+                <a:cs typeface="Arial"/>
+              </a:defRPr>
+            </a:lvl4pPr>
+            <a:lvl5pPr>
+              <a:buNone/>
+              <a:defRPr sz="2325" b="1">
+                <a:solidFill>
+                  <a:srgbClr val="245844"/>
+                </a:solidFill>
+                <a:latin typeface="Arial"/>
+                <a:ea typeface="Arial"/>
+                <a:cs typeface="Arial"/>
+              </a:defRPr>
+            </a:lvl5pPr>
+            <a:lvl6pPr>
+              <a:buNone/>
+              <a:defRPr sz="2325" b="1">
+                <a:solidFill>
+                  <a:srgbClr val="245844"/>
+                </a:solidFill>
+                <a:latin typeface="Arial"/>
+                <a:ea typeface="Arial"/>
+                <a:cs typeface="Arial"/>
+              </a:defRPr>
+            </a:lvl6pPr>
+            <a:lvl7pPr>
+              <a:buNone/>
+              <a:defRPr sz="2325" b="1">
+                <a:solidFill>
+                  <a:srgbClr val="245844"/>
+                </a:solidFill>
+                <a:latin typeface="Arial"/>
+                <a:ea typeface="Arial"/>
+                <a:cs typeface="Arial"/>
+              </a:defRPr>
+            </a:lvl7pPr>
+            <a:lvl8pPr>
+              <a:buNone/>
+              <a:defRPr sz="2325" b="1">
+                <a:solidFill>
+                  <a:srgbClr val="245844"/>
+                </a:solidFill>
+                <a:latin typeface="Arial"/>
+                <a:ea typeface="Arial"/>
+                <a:cs typeface="Arial"/>
+              </a:defRPr>
+            </a:lvl8pPr>
+            <a:lvl9pPr>
+              <a:buNone/>
+              <a:defRPr sz="2325" b="1">
+                <a:solidFill>
+                  <a:srgbClr val="245844"/>
+                </a:solidFill>
+                <a:latin typeface="Arial"/>
+                <a:ea typeface="Arial"/>
+                <a:cs typeface="Arial"/>
+              </a:defRPr>
+            </a:lvl9pPr>
+          </a:lstStyle>
+          <a:p xmlns:a="http://schemas.openxmlformats.org/drawingml/2006/main">
+            <a:pPr>
+              <a:buNone/>
+              <a:defRPr sz="2325" b="1">
+                <a:solidFill>
+                  <a:srgbClr val="245844"/>
+                </a:solidFill>
+                <a:latin typeface="Arial"/>
+                <a:ea typeface="Arial"/>
+                <a:cs typeface="Arial"/>
+              </a:defRPr>
+            </a:pPr>
+            <a:r>
+              <a:rPr sz="2325" b="1">
+                <a:solidFill>
+                  <a:srgbClr val="245844"/>
+                </a:solidFill>
+                <a:latin typeface="Arial"/>
+                <a:ea typeface="Arial"/>
+                <a:cs typeface="Arial"/>
+              </a:rPr>
+              <a:t>Both models lost some F1 under blur.</a:t>
+            </a:r>
+          </a:p>
+        </p:txBody>
+      </p:sp>
+      <p:sp>
+        <p:nvSpPr>
+          <p:cNvPr id="6" name="">
+            <a:extLst xmlns:a="http://schemas.openxmlformats.org/drawingml/2006/main">
+              <a:ext uri="{FF2B5EF4-FFF2-40B4-BE49-F238E27FC236}">
+                <a16:creationId xmlns:a16="http://schemas.microsoft.com/office/drawing/2014/main" id="{F87C585E-2C29-41CA-BD50-BE0BD27FFA12}"/>
+              </a:ext>
+            </a:extLst>
+          </p:cNvPr>
+          <p:cNvSpPr>
+            <a:spLocks xmlns:a="http://schemas.openxmlformats.org/drawingml/2006/main" noGrp="1"/>
+          </p:cNvSpPr>
+          <p:nvPr/>
+        </p:nvSpPr>
+        <p:spPr>
+          <a:xfrm xmlns:a="http://schemas.openxmlformats.org/drawingml/2006/main">
+            <a:off x="609600" y="6048375"/>
+            <a:ext cx="10477500" cy="552450"/>
+          </a:xfrm>
+          <a:prstGeom xmlns:a="http://schemas.openxmlformats.org/drawingml/2006/main" prst="rect">
+            <a:avLst/>
+          </a:prstGeom>
+          <a:noFill xmlns:a="http://schemas.openxmlformats.org/drawingml/2006/main"/>
+          <a:ln xmlns:a="http://schemas.openxmlformats.org/drawingml/2006/main" w="0">
+            <a:noFill/>
+          </a:ln>
+        </p:spPr>
+        <p:txBody>
+          <a:bodyPr xmlns:a="http://schemas.openxmlformats.org/drawingml/2006/main" wrap="square" lIns="0" tIns="0" rIns="0" bIns="0" anchor="t">
+            <a:noAutofit/>
+          </a:bodyPr>
+          <a:lstStyle xmlns:a="http://schemas.openxmlformats.org/drawingml/2006/main">
+            <a:defPPr>
+              <a:defRPr sz="1725" b="0">
+                <a:solidFill>
+                  <a:srgbClr val="5D6864"/>
+                </a:solidFill>
+                <a:latin typeface="Arial"/>
+                <a:ea typeface="Arial"/>
+                <a:cs typeface="Arial"/>
+              </a:defRPr>
+            </a:defPPr>
+            <a:lvl1pPr>
+              <a:buNone/>
+              <a:defRPr sz="1725" b="0">
+                <a:solidFill>
+                  <a:srgbClr val="5D6864"/>
+                </a:solidFill>
+                <a:latin typeface="Arial"/>
+                <a:ea typeface="Arial"/>
+                <a:cs typeface="Arial"/>
+              </a:defRPr>
+            </a:lvl1pPr>
+            <a:lvl2pPr>
+              <a:buNone/>
+              <a:defRPr sz="1725" b="0">
+                <a:solidFill>
+                  <a:srgbClr val="5D6864"/>
+                </a:solidFill>
+                <a:latin typeface="Arial"/>
+                <a:ea typeface="Arial"/>
+                <a:cs typeface="Arial"/>
+              </a:defRPr>
+            </a:lvl2pPr>
+            <a:lvl3pPr>
+              <a:buNone/>
+              <a:defRPr sz="1725" b="0">
+                <a:solidFill>
+                  <a:srgbClr val="5D6864"/>
+                </a:solidFill>
+                <a:latin typeface="Arial"/>
+                <a:ea typeface="Arial"/>
+                <a:cs typeface="Arial"/>
+              </a:defRPr>
+            </a:lvl3pPr>
+            <a:lvl4pPr>
+              <a:buNone/>
+              <a:defRPr sz="1725" b="0">
+                <a:solidFill>
+                  <a:srgbClr val="5D6864"/>
+                </a:solidFill>
+                <a:latin typeface="Arial"/>
+                <a:ea typeface="Arial"/>
+                <a:cs typeface="Arial"/>
+              </a:defRPr>
+            </a:lvl4pPr>
+            <a:lvl5pPr>
+              <a:buNone/>
+              <a:defRPr sz="1725" b="0">
+                <a:solidFill>
+                  <a:srgbClr val="5D6864"/>
+                </a:solidFill>
+                <a:latin typeface="Arial"/>
+                <a:ea typeface="Arial"/>
+                <a:cs typeface="Arial"/>
+              </a:defRPr>
+            </a:lvl5pPr>
+            <a:lvl6pPr>
+              <a:buNone/>
+              <a:defRPr sz="1725" b="0">
+                <a:solidFill>
+                  <a:srgbClr val="5D6864"/>
+                </a:solidFill>
+                <a:latin typeface="Arial"/>
+                <a:ea typeface="Arial"/>
+                <a:cs typeface="Arial"/>
+              </a:defRPr>
+            </a:lvl6pPr>
+            <a:lvl7pPr>
+              <a:buNone/>
+              <a:defRPr sz="1725" b="0">
+                <a:solidFill>
+                  <a:srgbClr val="5D6864"/>
+                </a:solidFill>
+                <a:latin typeface="Arial"/>
+                <a:ea typeface="Arial"/>
+                <a:cs typeface="Arial"/>
+              </a:defRPr>
+            </a:lvl7pPr>
+            <a:lvl8pPr>
+              <a:buNone/>
+              <a:defRPr sz="1725" b="0">
+                <a:solidFill>
+                  <a:srgbClr val="5D6864"/>
+                </a:solidFill>
+                <a:latin typeface="Arial"/>
+                <a:ea typeface="Arial"/>
+                <a:cs typeface="Arial"/>
+              </a:defRPr>
+            </a:lvl8pPr>
+            <a:lvl9pPr>
+              <a:buNone/>
+              <a:defRPr sz="1725" b="0">
+                <a:solidFill>
+                  <a:srgbClr val="5D6864"/>
+                </a:solidFill>
+                <a:latin typeface="Arial"/>
+                <a:ea typeface="Arial"/>
+                <a:cs typeface="Arial"/>
+              </a:defRPr>
+            </a:lvl9pPr>
+          </a:lstStyle>
+          <a:p xmlns:a="http://schemas.openxmlformats.org/drawingml/2006/main">
+            <a:pPr>
+              <a:buNone/>
+              <a:defRPr sz="1725" b="0">
+                <a:solidFill>
+                  <a:srgbClr val="5D6864"/>
+                </a:solidFill>
+                <a:latin typeface="Arial"/>
+                <a:ea typeface="Arial"/>
+                <a:cs typeface="Arial"/>
+              </a:defRPr>
+            </a:pPr>
+            <a:r>
+              <a:rPr sz="1725" b="0">
+                <a:solidFill>
+                  <a:srgbClr val="5D6864"/>
+                </a:solidFill>
+                <a:latin typeface="Arial"/>
+                <a:ea typeface="Arial"/>
+                <a:cs typeface="Arial"/>
+              </a:rPr>
+              <a:t>One synthetic severity per condition. This does not test new farms, devices or seasons.</a:t>
+            </a:r>
+          </a:p>
+        </p:txBody>
+      </p:sp>
+    </p:spTree>
+    <p:extLst>
+      <p:ext uri="{BB962C8B-B14F-4D97-AF65-F5344CB8AC3E}">
+        <p14:creationId xmlns:p14="http://schemas.microsoft.com/office/powerpoint/2010/main" val="46951431"/>
+      </p:ext>
+    </p:extLst>
+  </p:cSld>
+</p:sld>
+</file>
+
+<file path=ppt/slides/slide14.xml><?xml version="1.0" encoding="utf-8"?>
+<p:sld xmlns:p="http://schemas.openxmlformats.org/presentationml/2006/main">
+  <p:cSld>
+    <p:bg>
+      <p:bgPr>
+        <a:solidFill xmlns:a="http://schemas.openxmlformats.org/drawingml/2006/main">
+          <a:srgbClr val="FFFFFF"/>
+        </a:solidFill>
+      </p:bgPr>
+    </p:bg>
+    <p:spTree>
+      <p:nvGrpSpPr>
+        <p:cNvPr id="1" name=""/>
+        <p:cNvGrpSpPr/>
+        <p:nvPr/>
+      </p:nvGrpSpPr>
+      <p:grpSpPr>
+        <a:xfrm xmlns:a="http://schemas.openxmlformats.org/drawingml/2006/main"/>
+      </p:grpSpPr>
+      <p:sp>
+        <p:nvSpPr>
           <p:cNvPr id="12" name="">
             <a:extLst xmlns:a="http://schemas.openxmlformats.org/drawingml/2006/main">
               <a:ext uri="{FF2B5EF4-FFF2-40B4-BE49-F238E27FC236}">
@@ -8602,7 +11665,7 @@
                 <a:ea typeface="Arial"/>
                 <a:cs typeface="Arial"/>
               </a:rPr>
-              <a:t>12</a:t>
+              <a:t>14</a:t>
             </a:r>
           </a:p>
         </p:txBody>
@@ -10585,7 +13648,7 @@
           <p:cNvPr id="3" name="">
             <a:extLst xmlns:a="http://schemas.openxmlformats.org/drawingml/2006/main">
               <a:ext uri="{FF2B5EF4-FFF2-40B4-BE49-F238E27FC236}">
-                <a16:creationId xmlns:a16="http://schemas.microsoft.com/office/drawing/2014/main" id="{60387B6D-33B1-4FED-898B-F684C625CDBA}"/>
+                <a16:creationId xmlns:a16="http://schemas.microsoft.com/office/drawing/2014/main" id="{E22F2883-697D-4498-80DC-FE4271742052}"/>
               </a:ext>
             </a:extLst>
           </p:cNvPr>
@@ -10595,7 +13658,7 @@
           <p:nvPr/>
         </p:nvPicPr>
         <p:blipFill>
-          <a:blip xmlns:r="http://schemas.openxmlformats.org/officeDocument/2006/relationships" xmlns:a="http://schemas.openxmlformats.org/drawingml/2006/main" r:embed="Rb564bdb301654255"/>
+          <a:blip xmlns:r="http://schemas.openxmlformats.org/officeDocument/2006/relationships" xmlns:a="http://schemas.openxmlformats.org/drawingml/2006/main" r:embed="R2eb562a5f91f4ede"/>
           <a:stretch xmlns:a="http://schemas.openxmlformats.org/drawingml/2006/main"/>
         </p:blipFill>
         <p:spPr>
@@ -10781,7 +13844,7 @@
           <p:cNvPr id="5" name="">
             <a:extLst xmlns:a="http://schemas.openxmlformats.org/drawingml/2006/main">
               <a:ext uri="{FF2B5EF4-FFF2-40B4-BE49-F238E27FC236}">
-                <a16:creationId xmlns:a16="http://schemas.microsoft.com/office/drawing/2014/main" id="{8D7227BC-DE61-4EE9-9689-7C229F078E8A}"/>
+                <a16:creationId xmlns:a16="http://schemas.microsoft.com/office/drawing/2014/main" id="{B25D1CFE-E9A6-420F-BAB5-A48DAAE96EF9}"/>
               </a:ext>
             </a:extLst>
           </p:cNvPr>
@@ -10791,7 +13854,7 @@
           <p:nvPr/>
         </p:nvPicPr>
         <p:blipFill>
-          <a:blip xmlns:r="http://schemas.openxmlformats.org/officeDocument/2006/relationships" xmlns:a="http://schemas.openxmlformats.org/drawingml/2006/main" r:embed="R3488bdc89575479b"/>
+          <a:blip xmlns:r="http://schemas.openxmlformats.org/officeDocument/2006/relationships" xmlns:a="http://schemas.openxmlformats.org/drawingml/2006/main" r:embed="R1d0f5cf8d8c34318"/>
           <a:stretch xmlns:a="http://schemas.openxmlformats.org/drawingml/2006/main"/>
         </p:blipFill>
         <p:spPr>
@@ -10977,7 +14040,7 @@
           <p:cNvPr id="7" name="">
             <a:extLst xmlns:a="http://schemas.openxmlformats.org/drawingml/2006/main">
               <a:ext uri="{FF2B5EF4-FFF2-40B4-BE49-F238E27FC236}">
-                <a16:creationId xmlns:a16="http://schemas.microsoft.com/office/drawing/2014/main" id="{03024481-2EEC-4782-A7BA-D4DDB00D275E}"/>
+                <a16:creationId xmlns:a16="http://schemas.microsoft.com/office/drawing/2014/main" id="{1C9B3888-CD77-48FB-82C8-62597AE4203B}"/>
               </a:ext>
             </a:extLst>
           </p:cNvPr>
@@ -10987,7 +14050,7 @@
           <p:nvPr/>
         </p:nvPicPr>
         <p:blipFill>
-          <a:blip xmlns:r="http://schemas.openxmlformats.org/officeDocument/2006/relationships" xmlns:a="http://schemas.openxmlformats.org/drawingml/2006/main" r:embed="R22edbfc17ae84613"/>
+          <a:blip xmlns:r="http://schemas.openxmlformats.org/officeDocument/2006/relationships" xmlns:a="http://schemas.openxmlformats.org/drawingml/2006/main" r:embed="R24166e1ed18f471e"/>
           <a:stretch xmlns:a="http://schemas.openxmlformats.org/drawingml/2006/main"/>
         </p:blipFill>
         <p:spPr>
@@ -11689,7 +14752,7 @@
         <p:spPr>
           <a:xfrm xmlns:a="http://schemas.openxmlformats.org/drawingml/2006/main">
             <a:off x="609600" y="6048375"/>
-            <a:ext cx="10287000" cy="552450"/>
+            <a:ext cx="10477500" cy="552450"/>
           </a:xfrm>
           <a:prstGeom xmlns:a="http://schemas.openxmlformats.org/drawingml/2006/main" prst="rect">
             <a:avLst/>
@@ -11814,6 +14877,30 @@
               </a:defRPr>
             </a:lvl9pPr>
           </a:lstStyle>
+          <a:p xmlns:a="http://schemas.openxmlformats.org/drawingml/2006/main">
+            <a:pPr>
+              <a:buNone/>
+              <a:defRPr sz="1725" b="0">
+                <a:solidFill>
+                  <a:srgbClr val="5D6864"/>
+                </a:solidFill>
+                <a:latin typeface="Arial"/>
+                <a:ea typeface="Arial"/>
+                <a:cs typeface="Arial"/>
+              </a:defRPr>
+            </a:pPr>
+            <a:r>
+              <a:rPr sz="1725" b="0">
+                <a:solidFill>
+                  <a:srgbClr val="5D6864"/>
+                </a:solidFill>
+                <a:latin typeface="Arial"/>
+                <a:ea typeface="Arial"/>
+                <a:cs typeface="Arial"/>
+              </a:rPr>
+              <a:t>Small, expert-labelled field dataset: practical for transfer learning.</a:t>
+            </a:r>
+          </a:p>
           <a:p xmlns:a="http://schemas.openxmlformats.org/drawingml/2006/main">
             <a:pPr>
               <a:buNone/>
@@ -11883,6 +14970,7 @@
               </a:defRPr>
             </a:defPPr>
             <a:lvl1pPr>
+              <a:buNone/>
               <a:defRPr sz="1725" b="0">
                 <a:solidFill>
                   <a:srgbClr val="5D6864"/>
@@ -11893,6 +14981,7 @@
               </a:defRPr>
             </a:lvl1pPr>
             <a:lvl2pPr>
+              <a:buNone/>
               <a:defRPr sz="1725" b="0">
                 <a:solidFill>
                   <a:srgbClr val="5D6864"/>
@@ -11903,6 +14992,7 @@
               </a:defRPr>
             </a:lvl2pPr>
             <a:lvl3pPr>
+              <a:buNone/>
               <a:defRPr sz="1725" b="0">
                 <a:solidFill>
                   <a:srgbClr val="5D6864"/>
@@ -11913,6 +15003,7 @@
               </a:defRPr>
             </a:lvl3pPr>
             <a:lvl4pPr>
+              <a:buNone/>
               <a:defRPr sz="1725" b="0">
                 <a:solidFill>
                   <a:srgbClr val="5D6864"/>
@@ -11923,6 +15014,7 @@
               </a:defRPr>
             </a:lvl4pPr>
             <a:lvl5pPr>
+              <a:buNone/>
               <a:defRPr sz="1725" b="0">
                 <a:solidFill>
                   <a:srgbClr val="5D6864"/>
@@ -11933,6 +15025,7 @@
               </a:defRPr>
             </a:lvl5pPr>
             <a:lvl6pPr>
+              <a:buNone/>
               <a:defRPr sz="1725" b="0">
                 <a:solidFill>
                   <a:srgbClr val="5D6864"/>
@@ -11943,6 +15036,7 @@
               </a:defRPr>
             </a:lvl6pPr>
             <a:lvl7pPr>
+              <a:buNone/>
               <a:defRPr sz="1725" b="0">
                 <a:solidFill>
                   <a:srgbClr val="5D6864"/>
@@ -11953,6 +15047,7 @@
               </a:defRPr>
             </a:lvl7pPr>
             <a:lvl8pPr>
+              <a:buNone/>
               <a:defRPr sz="1725" b="0">
                 <a:solidFill>
                   <a:srgbClr val="5D6864"/>
@@ -11963,6 +15058,7 @@
               </a:defRPr>
             </a:lvl8pPr>
             <a:lvl9pPr>
+              <a:buNone/>
               <a:defRPr sz="1725" b="0">
                 <a:solidFill>
                   <a:srgbClr val="5D6864"/>
@@ -11975,6 +15071,7 @@
           </a:lstStyle>
           <a:p xmlns:a="http://schemas.openxmlformats.org/drawingml/2006/main">
             <a:pPr>
+              <a:buNone/>
               <a:defRPr sz="1725" b="0">
                 <a:solidFill>
                   <a:srgbClr val="5D6864"/>
@@ -12368,7 +15465,7 @@
           <p:cNvPr id="3" name="">
             <a:extLst xmlns:a="http://schemas.openxmlformats.org/drawingml/2006/main">
               <a:ext uri="{FF2B5EF4-FFF2-40B4-BE49-F238E27FC236}">
-                <a16:creationId xmlns:a16="http://schemas.microsoft.com/office/drawing/2014/main" id="{ED48927E-5E93-4FD7-B539-82169634C83E}"/>
+                <a16:creationId xmlns:a16="http://schemas.microsoft.com/office/drawing/2014/main" id="{213BAD8B-02FF-45EE-9FD1-13E1C588120B}"/>
               </a:ext>
             </a:extLst>
           </p:cNvPr>
@@ -13611,7 +16708,7 @@
         <p:spPr>
           <a:xfrm xmlns:a="http://schemas.openxmlformats.org/drawingml/2006/main">
             <a:off x="609600" y="6048375"/>
-            <a:ext cx="10287000" cy="552450"/>
+            <a:ext cx="10572750" cy="552450"/>
           </a:xfrm>
           <a:prstGeom xmlns:a="http://schemas.openxmlformats.org/drawingml/2006/main" prst="rect">
             <a:avLst/>
@@ -13757,7 +16854,7 @@
                 <a:ea typeface="Arial"/>
                 <a:cs typeface="Arial"/>
               </a:rPr>
-              <a:t>Two models × two settings × three seeds = 12 runs.</a:t>
+              <a:t>Published B/16-224 ImageNet zero-shot: SigLIP 2 78.2% versus original SigLIP 76.2%.</a:t>
             </a:r>
           </a:p>
           <a:p xmlns:a="http://schemas.openxmlformats.org/drawingml/2006/main">
@@ -13781,7 +16878,7 @@
                 <a:ea typeface="Arial"/>
                 <a:cs typeface="Arial"/>
               </a:rPr>
-              <a:t>Validation selected each checkpoint. All runs fit a 4 GB GPU.</a:t>
+              <a:t>This motivated selection. Our experiment uses images and supervised labels.</a:t>
             </a:r>
           </a:p>
         </p:txBody>
@@ -13829,6 +16926,7 @@
               </a:defRPr>
             </a:defPPr>
             <a:lvl1pPr>
+              <a:buNone/>
               <a:defRPr sz="2025" b="0">
                 <a:solidFill>
                   <a:srgbClr val="22362F"/>
@@ -13839,6 +16937,7 @@
               </a:defRPr>
             </a:lvl1pPr>
             <a:lvl2pPr>
+              <a:buNone/>
               <a:defRPr sz="2025" b="0">
                 <a:solidFill>
                   <a:srgbClr val="22362F"/>
@@ -13849,6 +16948,7 @@
               </a:defRPr>
             </a:lvl2pPr>
             <a:lvl3pPr>
+              <a:buNone/>
               <a:defRPr sz="2025" b="0">
                 <a:solidFill>
                   <a:srgbClr val="22362F"/>
@@ -13859,6 +16959,7 @@
               </a:defRPr>
             </a:lvl3pPr>
             <a:lvl4pPr>
+              <a:buNone/>
               <a:defRPr sz="2025" b="0">
                 <a:solidFill>
                   <a:srgbClr val="22362F"/>
@@ -13869,6 +16970,7 @@
               </a:defRPr>
             </a:lvl4pPr>
             <a:lvl5pPr>
+              <a:buNone/>
               <a:defRPr sz="2025" b="0">
                 <a:solidFill>
                   <a:srgbClr val="22362F"/>
@@ -13879,6 +16981,7 @@
               </a:defRPr>
             </a:lvl5pPr>
             <a:lvl6pPr>
+              <a:buNone/>
               <a:defRPr sz="2025" b="0">
                 <a:solidFill>
                   <a:srgbClr val="22362F"/>
@@ -13889,6 +16992,7 @@
               </a:defRPr>
             </a:lvl6pPr>
             <a:lvl7pPr>
+              <a:buNone/>
               <a:defRPr sz="2025" b="0">
                 <a:solidFill>
                   <a:srgbClr val="22362F"/>
@@ -13899,6 +17003,7 @@
               </a:defRPr>
             </a:lvl7pPr>
             <a:lvl8pPr>
+              <a:buNone/>
               <a:defRPr sz="2025" b="0">
                 <a:solidFill>
                   <a:srgbClr val="22362F"/>
@@ -13909,6 +17014,7 @@
               </a:defRPr>
             </a:lvl8pPr>
             <a:lvl9pPr>
+              <a:buNone/>
               <a:defRPr sz="2025" b="0">
                 <a:solidFill>
                   <a:srgbClr val="22362F"/>
@@ -13921,6 +17027,7 @@
           </a:lstStyle>
           <a:p xmlns:a="http://schemas.openxmlformats.org/drawingml/2006/main">
             <a:pPr>
+              <a:buNone/>
               <a:defRPr sz="2025" b="0">
                 <a:solidFill>
                   <a:srgbClr val="22362F"/>
@@ -13987,6 +17094,7 @@
               </a:defRPr>
             </a:defPPr>
             <a:lvl1pPr>
+              <a:buNone/>
               <a:defRPr sz="2025" b="0">
                 <a:solidFill>
                   <a:srgbClr val="22362F"/>
@@ -13997,6 +17105,7 @@
               </a:defRPr>
             </a:lvl1pPr>
             <a:lvl2pPr>
+              <a:buNone/>
               <a:defRPr sz="2025" b="0">
                 <a:solidFill>
                   <a:srgbClr val="22362F"/>
@@ -14007,6 +17116,7 @@
               </a:defRPr>
             </a:lvl2pPr>
             <a:lvl3pPr>
+              <a:buNone/>
               <a:defRPr sz="2025" b="0">
                 <a:solidFill>
                   <a:srgbClr val="22362F"/>
@@ -14017,6 +17127,7 @@
               </a:defRPr>
             </a:lvl3pPr>
             <a:lvl4pPr>
+              <a:buNone/>
               <a:defRPr sz="2025" b="0">
                 <a:solidFill>
                   <a:srgbClr val="22362F"/>
@@ -14027,6 +17138,7 @@
               </a:defRPr>
             </a:lvl4pPr>
             <a:lvl5pPr>
+              <a:buNone/>
               <a:defRPr sz="2025" b="0">
                 <a:solidFill>
                   <a:srgbClr val="22362F"/>
@@ -14037,6 +17149,7 @@
               </a:defRPr>
             </a:lvl5pPr>
             <a:lvl6pPr>
+              <a:buNone/>
               <a:defRPr sz="2025" b="0">
                 <a:solidFill>
                   <a:srgbClr val="22362F"/>
@@ -14047,6 +17160,7 @@
               </a:defRPr>
             </a:lvl6pPr>
             <a:lvl7pPr>
+              <a:buNone/>
               <a:defRPr sz="2025" b="0">
                 <a:solidFill>
                   <a:srgbClr val="22362F"/>
@@ -14057,6 +17171,7 @@
               </a:defRPr>
             </a:lvl7pPr>
             <a:lvl8pPr>
+              <a:buNone/>
               <a:defRPr sz="2025" b="0">
                 <a:solidFill>
                   <a:srgbClr val="22362F"/>
@@ -14067,6 +17182,7 @@
               </a:defRPr>
             </a:lvl8pPr>
             <a:lvl9pPr>
+              <a:buNone/>
               <a:defRPr sz="2025" b="0">
                 <a:solidFill>
                   <a:srgbClr val="22362F"/>
@@ -14079,6 +17195,7 @@
           </a:lstStyle>
           <a:p xmlns:a="http://schemas.openxmlformats.org/drawingml/2006/main">
             <a:pPr>
+              <a:buNone/>
               <a:defRPr sz="2025" b="0">
                 <a:solidFill>
                   <a:srgbClr val="22362F"/>
@@ -14098,6 +17215,174 @@
                 <a:cs typeface="Arial"/>
               </a:rPr>
               <a:t>Classifier: uses those values to predict one of three labels.</a:t>
+            </a:r>
+          </a:p>
+        </p:txBody>
+      </p:sp>
+      <p:sp>
+        <p:nvSpPr>
+          <p:cNvPr id="12" name="">
+            <a:extLst xmlns:a="http://schemas.openxmlformats.org/drawingml/2006/main">
+              <a:ext uri="{FF2B5EF4-FFF2-40B4-BE49-F238E27FC236}">
+                <a16:creationId xmlns:a16="http://schemas.microsoft.com/office/drawing/2014/main" id="{7C493F9E-5A60-4ABD-BD0D-BA5D44D04A53}"/>
+              </a:ext>
+            </a:extLst>
+          </p:cNvPr>
+          <p:cNvSpPr>
+            <a:spLocks xmlns:a="http://schemas.openxmlformats.org/drawingml/2006/main" noGrp="1"/>
+          </p:cNvSpPr>
+          <p:nvPr/>
+        </p:nvSpPr>
+        <p:spPr>
+          <a:xfrm xmlns:a="http://schemas.openxmlformats.org/drawingml/2006/main">
+            <a:off x="609600" y="981075"/>
+            <a:ext cx="10972800" cy="276225"/>
+          </a:xfrm>
+          <a:prstGeom xmlns:a="http://schemas.openxmlformats.org/drawingml/2006/main" prst="rect">
+            <a:avLst/>
+          </a:prstGeom>
+          <a:noFill xmlns:a="http://schemas.openxmlformats.org/drawingml/2006/main"/>
+          <a:ln xmlns:a="http://schemas.openxmlformats.org/drawingml/2006/main" w="0">
+            <a:noFill/>
+          </a:ln>
+        </p:spPr>
+        <p:txBody>
+          <a:bodyPr xmlns:a="http://schemas.openxmlformats.org/drawingml/2006/main" wrap="square" lIns="0" tIns="0" rIns="0" bIns="0" anchor="t">
+            <a:noAutofit/>
+          </a:bodyPr>
+          <a:lstStyle xmlns:a="http://schemas.openxmlformats.org/drawingml/2006/main">
+            <a:defPPr>
+              <a:defRPr sz="1725" b="0">
+                <a:solidFill>
+                  <a:srgbClr val="245844"/>
+                </a:solidFill>
+                <a:latin typeface="Arial"/>
+                <a:ea typeface="Arial"/>
+                <a:cs typeface="Arial"/>
+              </a:defRPr>
+            </a:defPPr>
+            <a:lvl1pPr>
+              <a:buNone/>
+              <a:defRPr sz="1725" b="0">
+                <a:solidFill>
+                  <a:srgbClr val="245844"/>
+                </a:solidFill>
+                <a:latin typeface="Arial"/>
+                <a:ea typeface="Arial"/>
+                <a:cs typeface="Arial"/>
+              </a:defRPr>
+            </a:lvl1pPr>
+            <a:lvl2pPr>
+              <a:buNone/>
+              <a:defRPr sz="1725" b="0">
+                <a:solidFill>
+                  <a:srgbClr val="245844"/>
+                </a:solidFill>
+                <a:latin typeface="Arial"/>
+                <a:ea typeface="Arial"/>
+                <a:cs typeface="Arial"/>
+              </a:defRPr>
+            </a:lvl2pPr>
+            <a:lvl3pPr>
+              <a:buNone/>
+              <a:defRPr sz="1725" b="0">
+                <a:solidFill>
+                  <a:srgbClr val="245844"/>
+                </a:solidFill>
+                <a:latin typeface="Arial"/>
+                <a:ea typeface="Arial"/>
+                <a:cs typeface="Arial"/>
+              </a:defRPr>
+            </a:lvl3pPr>
+            <a:lvl4pPr>
+              <a:buNone/>
+              <a:defRPr sz="1725" b="0">
+                <a:solidFill>
+                  <a:srgbClr val="245844"/>
+                </a:solidFill>
+                <a:latin typeface="Arial"/>
+                <a:ea typeface="Arial"/>
+                <a:cs typeface="Arial"/>
+              </a:defRPr>
+            </a:lvl4pPr>
+            <a:lvl5pPr>
+              <a:buNone/>
+              <a:defRPr sz="1725" b="0">
+                <a:solidFill>
+                  <a:srgbClr val="245844"/>
+                </a:solidFill>
+                <a:latin typeface="Arial"/>
+                <a:ea typeface="Arial"/>
+                <a:cs typeface="Arial"/>
+              </a:defRPr>
+            </a:lvl5pPr>
+            <a:lvl6pPr>
+              <a:buNone/>
+              <a:defRPr sz="1725" b="0">
+                <a:solidFill>
+                  <a:srgbClr val="245844"/>
+                </a:solidFill>
+                <a:latin typeface="Arial"/>
+                <a:ea typeface="Arial"/>
+                <a:cs typeface="Arial"/>
+              </a:defRPr>
+            </a:lvl6pPr>
+            <a:lvl7pPr>
+              <a:buNone/>
+              <a:defRPr sz="1725" b="0">
+                <a:solidFill>
+                  <a:srgbClr val="245844"/>
+                </a:solidFill>
+                <a:latin typeface="Arial"/>
+                <a:ea typeface="Arial"/>
+                <a:cs typeface="Arial"/>
+              </a:defRPr>
+            </a:lvl7pPr>
+            <a:lvl8pPr>
+              <a:buNone/>
+              <a:defRPr sz="1725" b="0">
+                <a:solidFill>
+                  <a:srgbClr val="245844"/>
+                </a:solidFill>
+                <a:latin typeface="Arial"/>
+                <a:ea typeface="Arial"/>
+                <a:cs typeface="Arial"/>
+              </a:defRPr>
+            </a:lvl8pPr>
+            <a:lvl9pPr>
+              <a:buNone/>
+              <a:defRPr sz="1725" b="0">
+                <a:solidFill>
+                  <a:srgbClr val="245844"/>
+                </a:solidFill>
+                <a:latin typeface="Arial"/>
+                <a:ea typeface="Arial"/>
+                <a:cs typeface="Arial"/>
+              </a:defRPr>
+            </a:lvl9pPr>
+          </a:lstStyle>
+          <a:p xmlns:a="http://schemas.openxmlformats.org/drawingml/2006/main">
+            <a:pPr>
+              <a:buNone/>
+              <a:defRPr sz="1725" b="0">
+                <a:solidFill>
+                  <a:srgbClr val="245844"/>
+                </a:solidFill>
+                <a:latin typeface="Arial"/>
+                <a:ea typeface="Arial"/>
+                <a:cs typeface="Arial"/>
+              </a:defRPr>
+            </a:pPr>
+            <a:r>
+              <a:rPr sz="1725" b="0">
+                <a:solidFill>
+                  <a:srgbClr val="245844"/>
+                </a:solidFill>
+                <a:latin typeface="Arial"/>
+                <a:ea typeface="Arial"/>
+                <a:cs typeface="Arial"/>
+              </a:rPr>
+              <a:t>Public 2025 model and established baseline. All runs fit a 4 GB GPU.</a:t>
             </a:r>
           </a:p>
         </p:txBody>
@@ -14472,7 +17757,7 @@
           <p:cNvPr id="3" name="Chart">
             <a:extLst xmlns:a="http://schemas.openxmlformats.org/drawingml/2006/main">
               <a:ext uri="{FF2B5EF4-FFF2-40B4-BE49-F238E27FC236}">
-                <a16:creationId xmlns:a16="http://schemas.microsoft.com/office/drawing/2014/main" id="{1E3F439C-A12B-4224-8E3B-33F56A8A587A}"/>
+                <a16:creationId xmlns:a16="http://schemas.microsoft.com/office/drawing/2014/main" id="{8A65B4C0-2076-4A73-974A-A477FAA26379}"/>
               </a:ext>
             </a:extLst>
           </p:cNvPr>
@@ -14485,7 +17770,7 @@
         </p:xfrm>
         <a:graphic xmlns:a="http://schemas.openxmlformats.org/drawingml/2006/main">
           <a:graphicData uri="http://schemas.openxmlformats.org/drawingml/2006/chart">
-            <c:chart xmlns:r="http://schemas.openxmlformats.org/officeDocument/2006/relationships" xmlns:c="http://schemas.openxmlformats.org/drawingml/2006/chart" r:id="Rc0620e2b9c4a42a0"/>
+            <c:chart xmlns:r="http://schemas.openxmlformats.org/officeDocument/2006/relationships" xmlns:c="http://schemas.openxmlformats.org/drawingml/2006/chart" r:id="Rc9339718a9ab45b5"/>
           </a:graphicData>
         </a:graphic>
       </p:graphicFrame>
@@ -15747,7 +19032,7 @@
           <p:cNvPr id="3" name="Chart">
             <a:extLst xmlns:a="http://schemas.openxmlformats.org/drawingml/2006/main">
               <a:ext uri="{FF2B5EF4-FFF2-40B4-BE49-F238E27FC236}">
-                <a16:creationId xmlns:a16="http://schemas.microsoft.com/office/drawing/2014/main" id="{ADCAD6F9-ECD9-426F-8FE4-1277F9294A35}"/>
+                <a16:creationId xmlns:a16="http://schemas.microsoft.com/office/drawing/2014/main" id="{22410109-38EB-496E-9E9A-AA5711BC1DBC}"/>
               </a:ext>
             </a:extLst>
           </p:cNvPr>
@@ -15760,7 +19045,7 @@
         </p:xfrm>
         <a:graphic xmlns:a="http://schemas.openxmlformats.org/drawingml/2006/main">
           <a:graphicData uri="http://schemas.openxmlformats.org/drawingml/2006/chart">
-            <c:chart xmlns:r="http://schemas.openxmlformats.org/officeDocument/2006/relationships" xmlns:c="http://schemas.openxmlformats.org/drawingml/2006/chart" r:id="Rffc8289360ef4249"/>
+            <c:chart xmlns:r="http://schemas.openxmlformats.org/officeDocument/2006/relationships" xmlns:c="http://schemas.openxmlformats.org/drawingml/2006/chart" r:id="Rc92222cea4494a1e"/>
           </a:graphicData>
         </a:graphic>
       </p:graphicFrame>
@@ -16902,7 +20187,7 @@
           <p:cNvPr id="3" name="">
             <a:extLst xmlns:a="http://schemas.openxmlformats.org/drawingml/2006/main">
               <a:ext uri="{FF2B5EF4-FFF2-40B4-BE49-F238E27FC236}">
-                <a16:creationId xmlns:a16="http://schemas.microsoft.com/office/drawing/2014/main" id="{5BB12D8E-FA0D-4920-9420-0F01ED63FBC1}"/>
+                <a16:creationId xmlns:a16="http://schemas.microsoft.com/office/drawing/2014/main" id="{A602E60E-29F2-4B28-8253-AD700EB4995C}"/>
               </a:ext>
             </a:extLst>
           </p:cNvPr>
@@ -16912,7 +20197,7 @@
           <p:nvPr/>
         </p:nvPicPr>
         <p:blipFill>
-          <a:blip xmlns:r="http://schemas.openxmlformats.org/officeDocument/2006/relationships" xmlns:a="http://schemas.openxmlformats.org/drawingml/2006/main" r:embed="Rfe56c96202484e8a"/>
+          <a:blip xmlns:r="http://schemas.openxmlformats.org/officeDocument/2006/relationships" xmlns:a="http://schemas.openxmlformats.org/drawingml/2006/main" r:embed="R49fb02a9ed6e4d24"/>
           <a:stretch xmlns:a="http://schemas.openxmlformats.org/drawingml/2006/main"/>
         </p:blipFill>
         <p:spPr>
@@ -16930,7 +20215,7 @@
           <p:cNvPr id="4" name="">
             <a:extLst xmlns:a="http://schemas.openxmlformats.org/drawingml/2006/main">
               <a:ext uri="{FF2B5EF4-FFF2-40B4-BE49-F238E27FC236}">
-                <a16:creationId xmlns:a16="http://schemas.microsoft.com/office/drawing/2014/main" id="{08FC78DC-8F87-448A-B640-559CDA0865ED}"/>
+                <a16:creationId xmlns:a16="http://schemas.microsoft.com/office/drawing/2014/main" id="{B842FB5B-E0B1-42C9-A66B-1590DEC13D48}"/>
               </a:ext>
             </a:extLst>
           </p:cNvPr>
@@ -16940,7 +20225,7 @@
           <p:nvPr/>
         </p:nvPicPr>
         <p:blipFill>
-          <a:blip xmlns:r="http://schemas.openxmlformats.org/officeDocument/2006/relationships" xmlns:a="http://schemas.openxmlformats.org/drawingml/2006/main" r:embed="R1a4ccddae10d43c0"/>
+          <a:blip xmlns:r="http://schemas.openxmlformats.org/officeDocument/2006/relationships" xmlns:a="http://schemas.openxmlformats.org/drawingml/2006/main" r:embed="R31fbbd44f4be4645"/>
           <a:stretch xmlns:a="http://schemas.openxmlformats.org/drawingml/2006/main"/>
         </p:blipFill>
         <p:spPr>
@@ -19704,7 +22989,7 @@
           <p:cNvPr id="3" name="">
             <a:extLst xmlns:a="http://schemas.openxmlformats.org/drawingml/2006/main">
               <a:ext uri="{FF2B5EF4-FFF2-40B4-BE49-F238E27FC236}">
-                <a16:creationId xmlns:a16="http://schemas.microsoft.com/office/drawing/2014/main" id="{2D06B13C-F5AE-4062-893F-CAE3D9EF0318}"/>
+                <a16:creationId xmlns:a16="http://schemas.microsoft.com/office/drawing/2014/main" id="{C0757B48-5990-4FB5-A68C-6E97F5057158}"/>
               </a:ext>
             </a:extLst>
           </p:cNvPr>
@@ -21435,7 +24720,7 @@
           <p:cNvPr id="4" name="">
             <a:extLst xmlns:a="http://schemas.openxmlformats.org/drawingml/2006/main">
               <a:ext uri="{FF2B5EF4-FFF2-40B4-BE49-F238E27FC236}">
-                <a16:creationId xmlns:a16="http://schemas.microsoft.com/office/drawing/2014/main" id="{4564C09F-4BA4-406D-A719-9721A31D3718}"/>
+                <a16:creationId xmlns:a16="http://schemas.microsoft.com/office/drawing/2014/main" id="{92C9D6AB-E25D-4729-9B3C-AC65EC5312B9}"/>
               </a:ext>
             </a:extLst>
           </p:cNvPr>
@@ -22265,7 +25550,7 @@
           <p:cNvPr id="6" name="">
             <a:extLst xmlns:a="http://schemas.openxmlformats.org/drawingml/2006/main">
               <a:ext uri="{FF2B5EF4-FFF2-40B4-BE49-F238E27FC236}">
-                <a16:creationId xmlns:a16="http://schemas.microsoft.com/office/drawing/2014/main" id="{E2F897FE-BD4D-42A7-B1D2-0FD0250452C5}"/>
+                <a16:creationId xmlns:a16="http://schemas.microsoft.com/office/drawing/2014/main" id="{2ED911F7-C25F-4AC4-B249-3586D01573CA}"/>
               </a:ext>
             </a:extLst>
           </p:cNvPr>

</xml_diff>

<commit_message>
Add final slide linking to the public GitHub repository
</commit_message>
<xml_diff>
--- a/report/presentation/bean_leaf_presentation.pptx
+++ b/report/presentation/bean_leaf_presentation.pptx
@@ -1,27 +1,28 @@
 
 <file path=ppt/presentation.xml><?xml version="1.0" encoding="utf-8"?>
-<p:presentation xmlns:p="http://schemas.openxmlformats.org/presentationml/2006/main">
+<p:presentation xmlns:p="http://schemas.openxmlformats.org/presentationml/2006/main" xmlns:r="http://schemas.openxmlformats.org/officeDocument/2006/relationships">
   <p:sldMasterIdLst>
-    <p:sldMasterId xmlns:r="http://schemas.openxmlformats.org/officeDocument/2006/relationships" id="2147483648" r:id="R8d1e29fb2610412a"/>
+    <p:sldMasterId id="2147483648" r:id="R8d1e29fb2610412a"/>
   </p:sldMasterIdLst>
   <p:notesMasterIdLst>
-    <p:notesMasterId xmlns:r="http://schemas.openxmlformats.org/officeDocument/2006/relationships" r:id="Raeed584cf18a40c8"/>
+    <p:notesMasterId r:id="Raeed584cf18a40c8"/>
   </p:notesMasterIdLst>
   <p:sldIdLst>
-    <p:sldId xmlns:r="http://schemas.openxmlformats.org/officeDocument/2006/relationships" id="256" r:id="R8c6761a122064e61"/>
-    <p:sldId xmlns:r="http://schemas.openxmlformats.org/officeDocument/2006/relationships" id="257" r:id="R20b70ea2929f4f6a"/>
-    <p:sldId xmlns:r="http://schemas.openxmlformats.org/officeDocument/2006/relationships" id="258" r:id="Rfc47d71c478c472a"/>
-    <p:sldId xmlns:r="http://schemas.openxmlformats.org/officeDocument/2006/relationships" id="259" r:id="R516643924a0c4969"/>
-    <p:sldId xmlns:r="http://schemas.openxmlformats.org/officeDocument/2006/relationships" id="260" r:id="R3c38a85682f54675"/>
-    <p:sldId xmlns:r="http://schemas.openxmlformats.org/officeDocument/2006/relationships" id="261" r:id="R461f2e87ed83426e"/>
-    <p:sldId xmlns:r="http://schemas.openxmlformats.org/officeDocument/2006/relationships" id="262" r:id="Rbc92ec54a8f14f89"/>
-    <p:sldId xmlns:r="http://schemas.openxmlformats.org/officeDocument/2006/relationships" id="263" r:id="Rdc2415126a0640d9"/>
-    <p:sldId xmlns:r="http://schemas.openxmlformats.org/officeDocument/2006/relationships" id="264" r:id="R2e368fee74a24384"/>
-    <p:sldId xmlns:r="http://schemas.openxmlformats.org/officeDocument/2006/relationships" id="265" r:id="Rc3791ca9d4364217"/>
-    <p:sldId xmlns:r="http://schemas.openxmlformats.org/officeDocument/2006/relationships" id="266" r:id="R2cb639a7cdcf425d"/>
-    <p:sldId xmlns:r="http://schemas.openxmlformats.org/officeDocument/2006/relationships" id="267" r:id="R33d6c93197dd41be"/>
-    <p:sldId xmlns:r="http://schemas.openxmlformats.org/officeDocument/2006/relationships" id="268" r:id="Rbb972cc46b4a4a49"/>
-    <p:sldId xmlns:r="http://schemas.openxmlformats.org/officeDocument/2006/relationships" id="269" r:id="Rcae02aa00ffe4546"/>
+    <p:sldId id="256" r:id="R8c6761a122064e61"/>
+    <p:sldId id="257" r:id="R20b70ea2929f4f6a"/>
+    <p:sldId id="258" r:id="Rfc47d71c478c472a"/>
+    <p:sldId id="259" r:id="R516643924a0c4969"/>
+    <p:sldId id="260" r:id="R3c38a85682f54675"/>
+    <p:sldId id="261" r:id="R461f2e87ed83426e"/>
+    <p:sldId id="262" r:id="Rbc92ec54a8f14f89"/>
+    <p:sldId id="263" r:id="Rdc2415126a0640d9"/>
+    <p:sldId id="264" r:id="R2e368fee74a24384"/>
+    <p:sldId id="265" r:id="Rc3791ca9d4364217"/>
+    <p:sldId id="266" r:id="R2cb639a7cdcf425d"/>
+    <p:sldId id="267" r:id="R33d6c93197dd41be"/>
+    <p:sldId id="268" r:id="Rbb972cc46b4a4a49"/>
+    <p:sldId id="269" r:id="Rcae02aa00ffe4546"/>
+    <p:sldId id="270" r:id="rIdRepositorySlide"/>
   </p:sldIdLst>
   <p:sldSz cx="12192000" cy="6858000"/>
   <p:notesSz cx="6858000" cy="9144000"/>
@@ -1035,6 +1036,76 @@
 </p:notes>
 </file>
 
+<file path=ppt/notesSlides/notesSlide15.xml><?xml version="1.0" encoding="utf-8"?>
+<p:notes xmlns:p="http://schemas.openxmlformats.org/presentationml/2006/main">
+  <p:cSld>
+    <p:spTree>
+      <p:nvGrpSpPr>
+        <p:cNvPr id="1" name=""/>
+        <p:cNvGrpSpPr/>
+        <p:nvPr/>
+      </p:nvGrpSpPr>
+      <p:grpSpPr>
+        <a:xfrm xmlns:a="http://schemas.openxmlformats.org/drawingml/2006/main"/>
+      </p:grpSpPr>
+      <p:sp>
+        <p:nvSpPr>
+          <p:cNvPr id="2" name="Slide Image Placeholder 1"/>
+          <p:cNvSpPr>
+            <a:spLocks xmlns:a="http://schemas.openxmlformats.org/drawingml/2006/main" noGrp="1"/>
+          </p:cNvSpPr>
+          <p:nvPr>
+            <p:ph type="sldImg" idx="0"/>
+          </p:nvPr>
+        </p:nvSpPr>
+        <p:spPr/>
+      </p:sp>
+      <p:sp>
+        <p:nvSpPr>
+          <p:cNvPr id="3" name="Notes Placeholder 2"/>
+          <p:cNvSpPr>
+            <a:spLocks xmlns:a="http://schemas.openxmlformats.org/drawingml/2006/main" noGrp="1"/>
+          </p:cNvSpPr>
+          <p:nvPr>
+            <p:ph type="body" idx="1"/>
+          </p:nvPr>
+        </p:nvSpPr>
+        <p:spPr/>
+        <p:txBody>
+          <a:bodyPr xmlns:a="http://schemas.openxmlformats.org/drawingml/2006/main"/>
+          <a:lstStyle xmlns:a="http://schemas.openxmlformats.org/drawingml/2006/main"/>
+          <a:p xmlns:a="http://schemas.openxmlformats.org/drawingml/2006/main">
+            <a:r>
+              <a:t>https://github.com/A1Prep/beans-vit-study-2026</a:t>
+            </a:r>
+          </a:p>
+        </p:txBody>
+      </p:sp>
+      <p:sp>
+        <p:nvSpPr>
+          <p:cNvPr id="4" name="Slide Number Placeholder 3"/>
+          <p:cNvSpPr>
+            <a:spLocks xmlns:a="http://schemas.openxmlformats.org/drawingml/2006/main" noGrp="1"/>
+          </p:cNvSpPr>
+          <p:nvPr>
+            <p:ph type="sldNum" idx="5"/>
+          </p:nvPr>
+        </p:nvSpPr>
+        <p:spPr/>
+        <p:txBody>
+          <a:bodyPr xmlns:a="http://schemas.openxmlformats.org/drawingml/2006/main"/>
+          <a:lstStyle xmlns:a="http://schemas.openxmlformats.org/drawingml/2006/main"/>
+          <a:p xmlns:a="http://schemas.openxmlformats.org/drawingml/2006/main"/>
+        </p:txBody>
+      </p:sp>
+    </p:spTree>
+  </p:cSld>
+  <p:clrMapOvr>
+    <a:masterClrMapping xmlns:a="http://schemas.openxmlformats.org/drawingml/2006/main"/>
+  </p:clrMapOvr>
+</p:notes>
+</file>
+
 <file path=ppt/notesSlides/notesSlide2.xml><?xml version="1.0" encoding="utf-8"?>
 <p:notes xmlns:p="http://schemas.openxmlformats.org/presentationml/2006/main">
   <p:cSld>
@@ -13282,6 +13353,194 @@
     <p:extLst>
       <p:ext uri="{BB962C8B-B14F-4D97-AF65-F5344CB8AC3E}">
         <p14:creationId xmlns:p14="http://schemas.microsoft.com/office/powerpoint/2010/main" val="2061399948"/>
+      </p:ext>
+    </p:extLst>
+  </p:cSld>
+</p:sld>
+</file>
+
+<file path=ppt/slides/slide15.xml><?xml version="1.0" encoding="utf-8"?>
+<p:sld xmlns:p="http://schemas.openxmlformats.org/presentationml/2006/main">
+  <p:cSld>
+    <p:bg>
+      <p:bgPr>
+        <a:solidFill xmlns:a="http://schemas.openxmlformats.org/drawingml/2006/main">
+          <a:srgbClr val="FFFFFF"/>
+        </a:solidFill>
+      </p:bgPr>
+    </p:bg>
+    <p:spTree>
+      <p:nvGrpSpPr>
+        <p:cNvPr id="1" name=""/>
+        <p:cNvGrpSpPr/>
+        <p:nvPr/>
+      </p:nvGrpSpPr>
+      <p:grpSpPr>
+        <a:xfrm xmlns:a="http://schemas.openxmlformats.org/drawingml/2006/main"/>
+      </p:grpSpPr>
+      <p:sp>
+        <p:nvSpPr>
+          <p:cNvPr id="2" name="">
+            <a:extLst xmlns:a="http://schemas.openxmlformats.org/drawingml/2006/main">
+              <a:ext uri="{FF2B5EF4-FFF2-40B4-BE49-F238E27FC236}">
+                <a16:creationId xmlns:a16="http://schemas.microsoft.com/office/drawing/2014/main" id="{9079817D-3185-4803-8D1C-2CBCD231878F}"/>
+              </a:ext>
+            </a:extLst>
+          </p:cNvPr>
+          <p:cNvSpPr>
+            <a:spLocks xmlns:a="http://schemas.openxmlformats.org/drawingml/2006/main" noGrp="1"/>
+          </p:cNvSpPr>
+          <p:nvPr/>
+        </p:nvSpPr>
+        <p:spPr>
+          <a:xfrm xmlns:a="http://schemas.openxmlformats.org/drawingml/2006/main">
+            <a:off x="609600" y="3000375"/>
+            <a:ext cx="10972800" cy="857250"/>
+          </a:xfrm>
+          <a:prstGeom xmlns:a="http://schemas.openxmlformats.org/drawingml/2006/main" prst="rect">
+            <a:avLst/>
+          </a:prstGeom>
+          <a:noFill xmlns:a="http://schemas.openxmlformats.org/drawingml/2006/main"/>
+          <a:ln xmlns:a="http://schemas.openxmlformats.org/drawingml/2006/main" w="0">
+            <a:noFill/>
+          </a:ln>
+        </p:spPr>
+        <p:txBody>
+          <a:bodyPr xmlns:a="http://schemas.openxmlformats.org/drawingml/2006/main" wrap="none" lIns="0" tIns="0" rIns="0" bIns="0" anchor="ctr">
+            <a:noAutofit/>
+          </a:bodyPr>
+          <a:lstStyle xmlns:a="http://schemas.openxmlformats.org/drawingml/2006/main">
+            <a:defPPr algn="ctr">
+              <a:defRPr sz="2700">
+                <a:solidFill>
+                  <a:srgbClr val="245844"/>
+                </a:solidFill>
+                <a:latin typeface="Arial"/>
+                <a:ea typeface="Arial"/>
+                <a:cs typeface="Arial"/>
+              </a:defRPr>
+            </a:defPPr>
+            <a:lvl1pPr algn="ctr">
+              <a:defRPr sz="2700">
+                <a:solidFill>
+                  <a:srgbClr val="245844"/>
+                </a:solidFill>
+                <a:latin typeface="Arial"/>
+                <a:ea typeface="Arial"/>
+                <a:cs typeface="Arial"/>
+              </a:defRPr>
+            </a:lvl1pPr>
+            <a:lvl2pPr algn="ctr">
+              <a:defRPr sz="2700">
+                <a:solidFill>
+                  <a:srgbClr val="245844"/>
+                </a:solidFill>
+                <a:latin typeface="Arial"/>
+                <a:ea typeface="Arial"/>
+                <a:cs typeface="Arial"/>
+              </a:defRPr>
+            </a:lvl2pPr>
+            <a:lvl3pPr algn="ctr">
+              <a:defRPr sz="2700">
+                <a:solidFill>
+                  <a:srgbClr val="245844"/>
+                </a:solidFill>
+                <a:latin typeface="Arial"/>
+                <a:ea typeface="Arial"/>
+                <a:cs typeface="Arial"/>
+              </a:defRPr>
+            </a:lvl3pPr>
+            <a:lvl4pPr algn="ctr">
+              <a:defRPr sz="2700">
+                <a:solidFill>
+                  <a:srgbClr val="245844"/>
+                </a:solidFill>
+                <a:latin typeface="Arial"/>
+                <a:ea typeface="Arial"/>
+                <a:cs typeface="Arial"/>
+              </a:defRPr>
+            </a:lvl4pPr>
+            <a:lvl5pPr algn="ctr">
+              <a:defRPr sz="2700">
+                <a:solidFill>
+                  <a:srgbClr val="245844"/>
+                </a:solidFill>
+                <a:latin typeface="Arial"/>
+                <a:ea typeface="Arial"/>
+                <a:cs typeface="Arial"/>
+              </a:defRPr>
+            </a:lvl5pPr>
+            <a:lvl6pPr algn="ctr">
+              <a:defRPr sz="2700">
+                <a:solidFill>
+                  <a:srgbClr val="245844"/>
+                </a:solidFill>
+                <a:latin typeface="Arial"/>
+                <a:ea typeface="Arial"/>
+                <a:cs typeface="Arial"/>
+              </a:defRPr>
+            </a:lvl6pPr>
+            <a:lvl7pPr algn="ctr">
+              <a:defRPr sz="2700">
+                <a:solidFill>
+                  <a:srgbClr val="245844"/>
+                </a:solidFill>
+                <a:latin typeface="Arial"/>
+                <a:ea typeface="Arial"/>
+                <a:cs typeface="Arial"/>
+              </a:defRPr>
+            </a:lvl7pPr>
+            <a:lvl8pPr algn="ctr">
+              <a:defRPr sz="2700">
+                <a:solidFill>
+                  <a:srgbClr val="245844"/>
+                </a:solidFill>
+                <a:latin typeface="Arial"/>
+                <a:ea typeface="Arial"/>
+                <a:cs typeface="Arial"/>
+              </a:defRPr>
+            </a:lvl8pPr>
+            <a:lvl9pPr algn="ctr">
+              <a:defRPr sz="2700">
+                <a:solidFill>
+                  <a:srgbClr val="245844"/>
+                </a:solidFill>
+                <a:latin typeface="Arial"/>
+                <a:ea typeface="Arial"/>
+                <a:cs typeface="Arial"/>
+              </a:defRPr>
+            </a:lvl9pPr>
+          </a:lstStyle>
+          <a:p xmlns:a="http://schemas.openxmlformats.org/drawingml/2006/main">
+            <a:pPr algn="ctr">
+              <a:defRPr sz="2700">
+                <a:solidFill>
+                  <a:srgbClr val="245844"/>
+                </a:solidFill>
+                <a:latin typeface="Arial"/>
+                <a:ea typeface="Arial"/>
+                <a:cs typeface="Arial"/>
+              </a:defRPr>
+            </a:pPr>
+            <a:r>
+              <a:rPr sz="2700">
+                <a:solidFill>
+                  <a:srgbClr val="245844"/>
+                </a:solidFill>
+                <a:latin typeface="Arial"/>
+                <a:ea typeface="Arial"/>
+                <a:cs typeface="Arial"/>
+                <a:hlinkClick xmlns:r="http://schemas.openxmlformats.org/officeDocument/2006/relationships" r:id="Rf05adace525345c0"/>
+              </a:rPr>
+              <a:t>https://github.com/A1Prep/beans-vit-study-2026</a:t>
+            </a:r>
+          </a:p>
+        </p:txBody>
+      </p:sp>
+    </p:spTree>
+    <p:extLst>
+      <p:ext uri="{BB962C8B-B14F-4D97-AF65-F5344CB8AC3E}">
+        <p14:creationId xmlns:p14="http://schemas.microsoft.com/office/powerpoint/2010/main" val="1117585964"/>
       </p:ext>
     </p:extLst>
   </p:cSld>

</xml_diff>